<commit_message>
Restructure three-pager per dictation and dual review passes
Page 2 now opens with the domains line and nests the five fronts inside
the org beat; fixes from adversarial dictation audit and neutral client
readthrough applied across all pages.

Co-Authored-By: Claude Fable 5 <noreply@anthropic.com>
Claude-Session: https://claude.ai/code/session_01A3Z3HHfQP1XqLkWjeuhpsJ
</commit_message>
<xml_diff>
--- a/proposal/TU_Org_AI_3pager_vDraft.pptx
+++ b/proposal/TU_Org_AI_3pager_vDraft.pptx
@@ -3599,7 +3599,7 @@
                 </a:solidFill>
                 <a:latin typeface="+mn-lt"/>
               </a:rPr>
-              <a:t>CONFIDENTIAL AND PROPRIETARY | © [#] McKinsey &amp; Company. </a:t>
+              <a:t>CONFIDENTIAL AND PROPRIETARY | © 2026 McKinsey &amp; Company. </a:t>
             </a:r>
           </a:p>
           <a:p>
@@ -34496,8 +34496,323 @@
         </p:nvSpPr>
         <p:spPr>
           <a:xfrm>
-            <a:off x="557784" y="1207008"/>
-            <a:ext cx="5440680" cy="256032"/>
+            <a:off x="557784" y="1188720"/>
+            <a:ext cx="11082528" cy="777240"/>
+          </a:xfrm>
+          <a:prstGeom prst="rect">
+            <a:avLst/>
+          </a:prstGeom>
+          <a:noFill/>
+        </p:spPr>
+        <p:txBody>
+          <a:bodyPr wrap="square" anchor="t" lIns="0" rIns="0" tIns="0" bIns="0">
+            <a:spAutoFit/>
+          </a:bodyPr>
+          <a:lstStyle/>
+          <a:p>
+            <a:pPr algn="l">
+              <a:lnSpc>
+                <a:spcPct val="108000"/>
+              </a:lnSpc>
+            </a:pPr>
+            <a:r>
+              <a:rPr sz="1350" b="0" i="0">
+                <a:solidFill>
+                  <a:srgbClr val="000000"/>
+                </a:solidFill>
+                <a:latin typeface="Arial"/>
+              </a:rPr>
+              <a:t>TU is embarking on a </a:t>
+            </a:r>
+            <a:r>
+              <a:rPr sz="1350" b="1" i="0">
+                <a:solidFill>
+                  <a:srgbClr val="000000"/>
+                </a:solidFill>
+                <a:latin typeface="Arial"/>
+              </a:rPr>
+              <a:t>top-down journey to identify and prioritize 2–3 enterprise domains for AI-led reimagination</a:t>
+            </a:r>
+            <a:r>
+              <a:rPr sz="1350" b="0" i="0">
+                <a:solidFill>
+                  <a:srgbClr val="000000"/>
+                </a:solidFill>
+                <a:latin typeface="Arial"/>
+              </a:rPr>
+              <a:t> — the few cross-functional domains that typically hold </a:t>
+            </a:r>
+            <a:r>
+              <a:rPr sz="1350" b="1" i="0">
+                <a:solidFill>
+                  <a:srgbClr val="000000"/>
+                </a:solidFill>
+                <a:latin typeface="Arial"/>
+              </a:rPr>
+              <a:t>40–50% of the enterprise value at stake</a:t>
+            </a:r>
+            <a:r>
+              <a:rPr sz="1350" b="0" i="0">
+                <a:solidFill>
+                  <a:srgbClr val="000000"/>
+                </a:solidFill>
+                <a:latin typeface="Arial"/>
+              </a:rPr>
+              <a:t>¹. TU leadership has begun an inventory of AI initiatives; the next step is a </a:t>
+            </a:r>
+            <a:r>
+              <a:rPr sz="1350" b="1" i="0">
+                <a:solidFill>
+                  <a:srgbClr val="000000"/>
+                </a:solidFill>
+                <a:latin typeface="Arial"/>
+              </a:rPr>
+              <a:t>framework to assess, size, and choose where to focus</a:t>
+            </a:r>
+          </a:p>
+        </p:txBody>
+      </p:sp>
+      <p:sp>
+        <p:nvSpPr>
+          <p:cNvPr id="4" name="Rounded Rectangle 3"/>
+          <p:cNvSpPr/>
+          <p:nvPr/>
+        </p:nvSpPr>
+        <p:spPr>
+          <a:xfrm>
+            <a:off x="557784" y="2212848"/>
+            <a:ext cx="11082528" cy="2761488"/>
+          </a:xfrm>
+          <a:prstGeom prst="roundRect">
+            <a:avLst>
+              <a:gd name="adj" fmla="val 3500"/>
+            </a:avLst>
+          </a:prstGeom>
+          <a:solidFill>
+            <a:srgbClr val="F0F4FF"/>
+          </a:solidFill>
+          <a:ln>
+            <a:noFill/>
+          </a:ln>
+          <a:effectLst/>
+        </p:spPr>
+        <p:style>
+          <a:lnRef idx="1">
+            <a:schemeClr val="accent1"/>
+          </a:lnRef>
+          <a:fillRef idx="3">
+            <a:schemeClr val="accent1"/>
+          </a:fillRef>
+          <a:effectRef idx="2">
+            <a:schemeClr val="accent1"/>
+          </a:effectRef>
+          <a:fontRef idx="minor">
+            <a:schemeClr val="lt1"/>
+          </a:fontRef>
+        </p:style>
+        <p:txBody>
+          <a:bodyPr rtlCol="0" anchor="ctr"/>
+          <a:lstStyle/>
+          <a:p>
+            <a:pPr algn="ctr"/>
+          </a:p>
+        </p:txBody>
+      </p:sp>
+      <p:sp>
+        <p:nvSpPr>
+          <p:cNvPr id="5" name="TextBox 4"/>
+          <p:cNvSpPr txBox="1"/>
+          <p:nvPr/>
+        </p:nvSpPr>
+        <p:spPr>
+          <a:xfrm>
+            <a:off x="822960" y="2359152"/>
+            <a:ext cx="10561320" cy="731520"/>
+          </a:xfrm>
+          <a:prstGeom prst="rect">
+            <a:avLst/>
+          </a:prstGeom>
+          <a:noFill/>
+        </p:spPr>
+        <p:txBody>
+          <a:bodyPr wrap="square" anchor="t" lIns="0" rIns="0" tIns="0" bIns="0">
+            <a:spAutoFit/>
+          </a:bodyPr>
+          <a:lstStyle/>
+          <a:p>
+            <a:pPr algn="l">
+              <a:lnSpc>
+                <a:spcPct val="108000"/>
+              </a:lnSpc>
+            </a:pPr>
+            <a:r>
+              <a:rPr sz="1350" b="1" i="0">
+                <a:solidFill>
+                  <a:srgbClr val="000000"/>
+                </a:solidFill>
+                <a:latin typeface="Arial"/>
+              </a:rPr>
+              <a:t>In parallel, TU must design the organization of the future.</a:t>
+            </a:r>
+            <a:r>
+              <a:rPr sz="1350" b="0" i="0">
+                <a:solidFill>
+                  <a:srgbClr val="000000"/>
+                </a:solidFill>
+                <a:latin typeface="Arial"/>
+              </a:rPr>
+              <a:t> It has evolved from credit bureau, to product company, to platform organization — </a:t>
+            </a:r>
+            <a:r>
+              <a:rPr sz="1350" b="1" i="0">
+                <a:solidFill>
+                  <a:srgbClr val="000000"/>
+                </a:solidFill>
+                <a:latin typeface="Arial"/>
+              </a:rPr>
+              <a:t>thin products on thick platforms</a:t>
+            </a:r>
+            <a:r>
+              <a:rPr sz="1350" b="0" i="0">
+                <a:solidFill>
+                  <a:srgbClr val="000000"/>
+                </a:solidFill>
+                <a:latin typeface="Arial"/>
+              </a:rPr>
+              <a:t> — while still early in its AI journey. In leadership's own framing: </a:t>
+            </a:r>
+            <a:r>
+              <a:rPr sz="1350" b="1" i="1">
+                <a:solidFill>
+                  <a:srgbClr val="2251FF"/>
+                </a:solidFill>
+                <a:latin typeface="Arial"/>
+              </a:rPr>
+              <a:t>a global-platforms era company, in a 2012-era structure.</a:t>
+            </a:r>
+            <a:r>
+              <a:rPr sz="1350" b="0" i="0">
+                <a:solidFill>
+                  <a:srgbClr val="000000"/>
+                </a:solidFill>
+                <a:latin typeface="Arial"/>
+              </a:rPr>
+              <a:t> The imperative spans five fronts:</a:t>
+            </a:r>
+          </a:p>
+        </p:txBody>
+      </p:sp>
+      <p:sp>
+        <p:nvSpPr>
+          <p:cNvPr id="6" name="Rounded Rectangle 5"/>
+          <p:cNvSpPr/>
+          <p:nvPr/>
+        </p:nvSpPr>
+        <p:spPr>
+          <a:xfrm>
+            <a:off x="822960" y="3364991"/>
+            <a:ext cx="2020824" cy="1389888"/>
+          </a:xfrm>
+          <a:prstGeom prst="roundRect">
+            <a:avLst>
+              <a:gd name="adj" fmla="val 9000"/>
+            </a:avLst>
+          </a:prstGeom>
+          <a:solidFill>
+            <a:srgbClr val="FFFFFF"/>
+          </a:solidFill>
+          <a:ln w="12700">
+            <a:solidFill>
+              <a:srgbClr val="2251FF"/>
+            </a:solidFill>
+          </a:ln>
+          <a:effectLst/>
+        </p:spPr>
+        <p:style>
+          <a:lnRef idx="1">
+            <a:schemeClr val="accent1"/>
+          </a:lnRef>
+          <a:fillRef idx="3">
+            <a:schemeClr val="accent1"/>
+          </a:fillRef>
+          <a:effectRef idx="2">
+            <a:schemeClr val="accent1"/>
+          </a:effectRef>
+          <a:fontRef idx="minor">
+            <a:schemeClr val="lt1"/>
+          </a:fontRef>
+        </p:style>
+        <p:txBody>
+          <a:bodyPr rtlCol="0" anchor="ctr"/>
+          <a:lstStyle/>
+          <a:p>
+            <a:pPr algn="ctr"/>
+          </a:p>
+        </p:txBody>
+      </p:sp>
+      <p:sp>
+        <p:nvSpPr>
+          <p:cNvPr id="7" name="Oval 6"/>
+          <p:cNvSpPr/>
+          <p:nvPr/>
+        </p:nvSpPr>
+        <p:spPr>
+          <a:xfrm>
+            <a:off x="804672" y="3246120"/>
+            <a:ext cx="256032" cy="256032"/>
+          </a:xfrm>
+          <a:prstGeom prst="ellipse">
+            <a:avLst/>
+          </a:prstGeom>
+          <a:solidFill>
+            <a:srgbClr val="2251FF"/>
+          </a:solidFill>
+          <a:ln>
+            <a:noFill/>
+          </a:ln>
+          <a:effectLst/>
+        </p:spPr>
+        <p:style>
+          <a:lnRef idx="1">
+            <a:schemeClr val="accent1"/>
+          </a:lnRef>
+          <a:fillRef idx="3">
+            <a:schemeClr val="accent1"/>
+          </a:fillRef>
+          <a:effectRef idx="2">
+            <a:schemeClr val="accent1"/>
+          </a:effectRef>
+          <a:fontRef idx="minor">
+            <a:schemeClr val="lt1"/>
+          </a:fontRef>
+        </p:style>
+        <p:txBody>
+          <a:bodyPr rtlCol="0" anchor="ctr" lIns="0" rIns="0" tIns="0" bIns="0" wrap="none"/>
+          <a:lstStyle/>
+          <a:p>
+            <a:pPr algn="ctr"/>
+            <a:r>
+              <a:rPr sz="1100" b="1">
+                <a:solidFill>
+                  <a:srgbClr val="FFFFFF"/>
+                </a:solidFill>
+                <a:latin typeface="Arial"/>
+              </a:rPr>
+              <a:t>1</a:t>
+            </a:r>
+          </a:p>
+        </p:txBody>
+      </p:sp>
+      <p:sp>
+        <p:nvSpPr>
+          <p:cNvPr id="8" name="TextBox 7"/>
+          <p:cNvSpPr txBox="1"/>
+          <p:nvPr/>
+        </p:nvSpPr>
+        <p:spPr>
+          <a:xfrm>
+            <a:off x="950976" y="3547872"/>
+            <a:ext cx="1764792" cy="548640"/>
           </a:xfrm>
           <a:prstGeom prst="rect">
             <a:avLst/>
@@ -34512,157 +34827,27 @@
           <a:p>
             <a:pPr algn="l"/>
             <a:r>
-              <a:rPr sz="1500" b="1" i="0">
+              <a:rPr sz="1250" b="1" i="0">
                 <a:solidFill>
-                  <a:srgbClr val="000000"/>
+                  <a:srgbClr val="061F79"/>
                 </a:solidFill>
                 <a:latin typeface="Arial"/>
               </a:rPr>
-              <a:t>A journey to prioritize where AI creates value</a:t>
-            </a:r>
-          </a:p>
-        </p:txBody>
-      </p:sp>
-      <p:cxnSp>
-        <p:nvCxnSpPr>
-          <p:cNvPr id="4" name="Connector 3"/>
-          <p:cNvCxnSpPr/>
-          <p:nvPr/>
-        </p:nvCxnSpPr>
-        <p:spPr>
-          <a:xfrm>
-            <a:off x="557784" y="1536192"/>
-            <a:ext cx="5440680" cy="0"/>
-          </a:xfrm>
-          <a:prstGeom prst="line">
-            <a:avLst/>
-          </a:prstGeom>
-          <a:ln w="9525">
-            <a:solidFill>
-              <a:srgbClr val="B0B3B8"/>
-            </a:solidFill>
-          </a:ln>
-          <a:effectLst/>
-        </p:spPr>
-        <p:style>
-          <a:lnRef idx="2">
-            <a:schemeClr val="accent1"/>
-          </a:lnRef>
-          <a:fillRef idx="0">
-            <a:schemeClr val="accent1"/>
-          </a:fillRef>
-          <a:effectRef idx="1">
-            <a:schemeClr val="accent1"/>
-          </a:effectRef>
-          <a:fontRef idx="minor">
-            <a:schemeClr val="tx1"/>
-          </a:fontRef>
-        </p:style>
-      </p:cxnSp>
-      <p:sp>
-        <p:nvSpPr>
-          <p:cNvPr id="5" name="TextBox 4"/>
-          <p:cNvSpPr txBox="1"/>
-          <p:nvPr/>
-        </p:nvSpPr>
-        <p:spPr>
-          <a:xfrm>
-            <a:off x="557784" y="1664208"/>
-            <a:ext cx="5440680" cy="1188720"/>
-          </a:xfrm>
-          <a:prstGeom prst="rect">
-            <a:avLst/>
-          </a:prstGeom>
-          <a:noFill/>
-        </p:spPr>
-        <p:txBody>
-          <a:bodyPr wrap="square" anchor="t" lIns="0" rIns="0" tIns="0" bIns="0">
-            <a:spAutoFit/>
-          </a:bodyPr>
-          <a:lstStyle/>
-          <a:p>
-            <a:pPr algn="l">
-              <a:lnSpc>
-                <a:spcPct val="100000"/>
-              </a:lnSpc>
-            </a:pPr>
-            <a:r>
-              <a:rPr sz="1300" b="0" i="0">
-                <a:solidFill>
-                  <a:srgbClr val="000000"/>
-                </a:solidFill>
-                <a:latin typeface="Arial"/>
-              </a:rPr>
-              <a:t>TU is embarking on a </a:t>
-            </a:r>
-            <a:r>
-              <a:rPr sz="1300" b="1" i="0">
-                <a:solidFill>
-                  <a:srgbClr val="000000"/>
-                </a:solidFill>
-                <a:latin typeface="Arial"/>
-              </a:rPr>
-              <a:t>top-down journey to identify and prioritize 2–3 enterprise domains</a:t>
-            </a:r>
-            <a:r>
-              <a:rPr sz="1300" b="0" i="0">
-                <a:solidFill>
-                  <a:srgbClr val="000000"/>
-                </a:solidFill>
-                <a:latin typeface="Arial"/>
-              </a:rPr>
-              <a:t> where AI-led reimagination can drive outsized value — the few cross-functional domains that typically hold </a:t>
-            </a:r>
-            <a:r>
-              <a:rPr sz="1300" b="1" i="0">
-                <a:solidFill>
-                  <a:srgbClr val="000000"/>
-                </a:solidFill>
-                <a:latin typeface="Arial"/>
-              </a:rPr>
-              <a:t>40–50% of the enterprise value at stake</a:t>
-            </a:r>
-          </a:p>
-          <a:p>
-            <a:pPr algn="l">
-              <a:lnSpc>
-                <a:spcPct val="100000"/>
-              </a:lnSpc>
-              <a:spcBef>
-                <a:spcPts val="700"/>
-              </a:spcBef>
-            </a:pPr>
-            <a:r>
-              <a:rPr sz="1300" b="0" i="0">
-                <a:solidFill>
-                  <a:srgbClr val="000000"/>
-                </a:solidFill>
-                <a:latin typeface="Arial"/>
-              </a:rPr>
-              <a:t>An inventory of AI initiatives is underway; the next step is a </a:t>
-            </a:r>
-            <a:r>
-              <a:rPr sz="1300" b="1" i="0">
-                <a:solidFill>
-                  <a:srgbClr val="000000"/>
-                </a:solidFill>
-                <a:latin typeface="Arial"/>
-              </a:rPr>
-              <a:t>framework to assess, size, and choose</a:t>
+              <a:t>Org hygiene</a:t>
             </a:r>
           </a:p>
         </p:txBody>
       </p:sp>
       <p:sp>
         <p:nvSpPr>
-          <p:cNvPr id="6" name="TextBox 5"/>
+          <p:cNvPr id="9" name="TextBox 8"/>
           <p:cNvSpPr txBox="1"/>
           <p:nvPr/>
         </p:nvSpPr>
         <p:spPr>
           <a:xfrm>
-            <a:off x="6190488" y="1207008"/>
-            <a:ext cx="5440680" cy="256032"/>
+            <a:off x="950976" y="4114800"/>
+            <a:ext cx="1764792" cy="566928"/>
           </a:xfrm>
           <a:prstGeom prst="rect">
             <a:avLst/>
@@ -34677,169 +34862,13 @@
           <a:p>
             <a:pPr algn="l"/>
             <a:r>
-              <a:rPr sz="1500" b="1" i="0">
+              <a:rPr sz="1050" b="0" i="0">
                 <a:solidFill>
                   <a:srgbClr val="000000"/>
                 </a:solidFill>
                 <a:latin typeface="Arial"/>
               </a:rPr>
-              <a:t>An organization built for a different era</a:t>
-            </a:r>
-          </a:p>
-        </p:txBody>
-      </p:sp>
-      <p:cxnSp>
-        <p:nvCxnSpPr>
-          <p:cNvPr id="7" name="Connector 6"/>
-          <p:cNvCxnSpPr/>
-          <p:nvPr/>
-        </p:nvCxnSpPr>
-        <p:spPr>
-          <a:xfrm>
-            <a:off x="6190488" y="1536192"/>
-            <a:ext cx="5440680" cy="0"/>
-          </a:xfrm>
-          <a:prstGeom prst="line">
-            <a:avLst/>
-          </a:prstGeom>
-          <a:ln w="9525">
-            <a:solidFill>
-              <a:srgbClr val="B0B3B8"/>
-            </a:solidFill>
-          </a:ln>
-          <a:effectLst/>
-        </p:spPr>
-        <p:style>
-          <a:lnRef idx="2">
-            <a:schemeClr val="accent1"/>
-          </a:lnRef>
-          <a:fillRef idx="0">
-            <a:schemeClr val="accent1"/>
-          </a:fillRef>
-          <a:effectRef idx="1">
-            <a:schemeClr val="accent1"/>
-          </a:effectRef>
-          <a:fontRef idx="minor">
-            <a:schemeClr val="tx1"/>
-          </a:fontRef>
-        </p:style>
-      </p:cxnSp>
-      <p:sp>
-        <p:nvSpPr>
-          <p:cNvPr id="8" name="TextBox 7"/>
-          <p:cNvSpPr txBox="1"/>
-          <p:nvPr/>
-        </p:nvSpPr>
-        <p:spPr>
-          <a:xfrm>
-            <a:off x="6190488" y="1664208"/>
-            <a:ext cx="5440680" cy="1188720"/>
-          </a:xfrm>
-          <a:prstGeom prst="rect">
-            <a:avLst/>
-          </a:prstGeom>
-          <a:noFill/>
-        </p:spPr>
-        <p:txBody>
-          <a:bodyPr wrap="square" anchor="t" lIns="0" rIns="0" tIns="0" bIns="0">
-            <a:spAutoFit/>
-          </a:bodyPr>
-          <a:lstStyle/>
-          <a:p>
-            <a:pPr algn="l">
-              <a:lnSpc>
-                <a:spcPct val="100000"/>
-              </a:lnSpc>
-            </a:pPr>
-            <a:r>
-              <a:rPr sz="1300" b="0" i="0">
-                <a:solidFill>
-                  <a:srgbClr val="000000"/>
-                </a:solidFill>
-                <a:latin typeface="Arial"/>
-              </a:rPr>
-              <a:t>TU has evolved from </a:t>
-            </a:r>
-            <a:r>
-              <a:rPr sz="1300" b="1" i="0">
-                <a:solidFill>
-                  <a:srgbClr val="000000"/>
-                </a:solidFill>
-                <a:latin typeface="Arial"/>
-              </a:rPr>
-              <a:t>credit bureau, to product company, to platform organization</a:t>
-            </a:r>
-            <a:r>
-              <a:rPr sz="1300" b="0" i="0">
-                <a:solidFill>
-                  <a:srgbClr val="000000"/>
-                </a:solidFill>
-                <a:latin typeface="Arial"/>
-              </a:rPr>
-              <a:t> — thin products on thick platforms — while still early in its AI journey</a:t>
-            </a:r>
-          </a:p>
-          <a:p>
-            <a:pPr algn="l">
-              <a:lnSpc>
-                <a:spcPct val="100000"/>
-              </a:lnSpc>
-              <a:spcBef>
-                <a:spcPts val="700"/>
-              </a:spcBef>
-            </a:pPr>
-            <a:r>
-              <a:rPr sz="1300" b="0" i="0">
-                <a:solidFill>
-                  <a:srgbClr val="000000"/>
-                </a:solidFill>
-                <a:latin typeface="Arial"/>
-              </a:rPr>
-              <a:t>In leadership's own words: </a:t>
-            </a:r>
-            <a:r>
-              <a:rPr sz="1300" b="1" i="1">
-                <a:solidFill>
-                  <a:srgbClr val="2251FF"/>
-                </a:solidFill>
-                <a:latin typeface="Arial"/>
-              </a:rPr>
-              <a:t>“a global-platforms era company, in a 2012-era structure”</a:t>
-            </a:r>
-          </a:p>
-        </p:txBody>
-      </p:sp>
-      <p:sp>
-        <p:nvSpPr>
-          <p:cNvPr id="9" name="TextBox 8"/>
-          <p:cNvSpPr txBox="1"/>
-          <p:nvPr/>
-        </p:nvSpPr>
-        <p:spPr>
-          <a:xfrm>
-            <a:off x="557784" y="3127248"/>
-            <a:ext cx="11082528" cy="274320"/>
-          </a:xfrm>
-          <a:prstGeom prst="rect">
-            <a:avLst/>
-          </a:prstGeom>
-          <a:noFill/>
-        </p:spPr>
-        <p:txBody>
-          <a:bodyPr wrap="square" anchor="t" lIns="0" rIns="0" tIns="0" bIns="0">
-            <a:spAutoFit/>
-          </a:bodyPr>
-          <a:lstStyle/>
-          <a:p>
-            <a:pPr algn="l"/>
-            <a:r>
-              <a:rPr sz="1500" b="1" i="0">
-                <a:solidFill>
-                  <a:srgbClr val="000000"/>
-                </a:solidFill>
-                <a:latin typeface="Arial"/>
-              </a:rPr>
-              <a:t>In parallel, an organizational imperative spans five fronts</a:t>
+              <a:t>Right-size spans, layers, and leadership density</a:t>
             </a:r>
           </a:p>
         </p:txBody>
@@ -34852,12 +34881,12 @@
         </p:nvSpPr>
         <p:spPr>
           <a:xfrm>
-            <a:off x="557784" y="3529584"/>
-            <a:ext cx="2139696" cy="1572768"/>
+            <a:off x="2948940" y="3364991"/>
+            <a:ext cx="2020824" cy="1389888"/>
           </a:xfrm>
           <a:prstGeom prst="roundRect">
             <a:avLst>
-              <a:gd name="adj" fmla="val 8000"/>
+              <a:gd name="adj" fmla="val 9000"/>
             </a:avLst>
           </a:prstGeom>
           <a:solidFill>
@@ -34900,8 +34929,8 @@
         </p:nvSpPr>
         <p:spPr>
           <a:xfrm>
-            <a:off x="539496" y="3410712"/>
-            <a:ext cx="274320" cy="274320"/>
+            <a:off x="2930652" y="3246120"/>
+            <a:ext cx="256032" cy="256032"/>
           </a:xfrm>
           <a:prstGeom prst="ellipse">
             <a:avLst/>
@@ -34934,13 +34963,13 @@
           <a:p>
             <a:pPr algn="ctr"/>
             <a:r>
-              <a:rPr sz="1200" b="1">
+              <a:rPr sz="1100" b="1">
                 <a:solidFill>
                   <a:srgbClr val="FFFFFF"/>
                 </a:solidFill>
                 <a:latin typeface="Arial"/>
               </a:rPr>
-              <a:t>1</a:t>
+              <a:t>2</a:t>
             </a:r>
           </a:p>
         </p:txBody>
@@ -34953,8 +34982,8 @@
         </p:nvSpPr>
         <p:spPr>
           <a:xfrm>
-            <a:off x="704088" y="3749039"/>
-            <a:ext cx="1847088" cy="566928"/>
+            <a:off x="3076956" y="3547872"/>
+            <a:ext cx="1764792" cy="548640"/>
           </a:xfrm>
           <a:prstGeom prst="rect">
             <a:avLst/>
@@ -34969,13 +34998,13 @@
           <a:p>
             <a:pPr algn="l"/>
             <a:r>
-              <a:rPr sz="1350" b="1" i="0">
+              <a:rPr sz="1250" b="1" i="0">
                 <a:solidFill>
                   <a:srgbClr val="061F79"/>
                 </a:solidFill>
                 <a:latin typeface="Arial"/>
               </a:rPr>
-              <a:t>Org hygiene</a:t>
+              <a:t>Platform org of the future</a:t>
             </a:r>
           </a:p>
         </p:txBody>
@@ -34988,8 +35017,8 @@
         </p:nvSpPr>
         <p:spPr>
           <a:xfrm>
-            <a:off x="704088" y="4334256"/>
-            <a:ext cx="1847088" cy="685800"/>
+            <a:off x="3076956" y="4114800"/>
+            <a:ext cx="1764792" cy="566928"/>
           </a:xfrm>
           <a:prstGeom prst="rect">
             <a:avLst/>
@@ -35004,13 +35033,13 @@
           <a:p>
             <a:pPr algn="l"/>
             <a:r>
-              <a:rPr sz="1150" b="0" i="0">
+              <a:rPr sz="1050" b="0" i="0">
                 <a:solidFill>
                   <a:srgbClr val="000000"/>
                 </a:solidFill>
                 <a:latin typeface="Arial"/>
               </a:rPr>
-              <a:t>Right-size spans, layers, and leadership density</a:t>
+              <a:t>Structure for the platform era, not the product era</a:t>
             </a:r>
           </a:p>
         </p:txBody>
@@ -35023,12 +35052,12 @@
         </p:nvSpPr>
         <p:spPr>
           <a:xfrm>
-            <a:off x="2793491" y="3529584"/>
-            <a:ext cx="2139696" cy="1572768"/>
+            <a:off x="5074920" y="3364991"/>
+            <a:ext cx="2020824" cy="1389888"/>
           </a:xfrm>
           <a:prstGeom prst="roundRect">
             <a:avLst>
-              <a:gd name="adj" fmla="val 8000"/>
+              <a:gd name="adj" fmla="val 9000"/>
             </a:avLst>
           </a:prstGeom>
           <a:solidFill>
@@ -35071,8 +35100,8 @@
         </p:nvSpPr>
         <p:spPr>
           <a:xfrm>
-            <a:off x="2775203" y="3410712"/>
-            <a:ext cx="274320" cy="274320"/>
+            <a:off x="5056632" y="3246120"/>
+            <a:ext cx="256032" cy="256032"/>
           </a:xfrm>
           <a:prstGeom prst="ellipse">
             <a:avLst/>
@@ -35105,13 +35134,13 @@
           <a:p>
             <a:pPr algn="ctr"/>
             <a:r>
-              <a:rPr sz="1200" b="1">
+              <a:rPr sz="1100" b="1">
                 <a:solidFill>
                   <a:srgbClr val="FFFFFF"/>
                 </a:solidFill>
                 <a:latin typeface="Arial"/>
               </a:rPr>
-              <a:t>2</a:t>
+              <a:t>3</a:t>
             </a:r>
           </a:p>
         </p:txBody>
@@ -35124,8 +35153,8 @@
         </p:nvSpPr>
         <p:spPr>
           <a:xfrm>
-            <a:off x="2939796" y="3749039"/>
-            <a:ext cx="1847088" cy="566928"/>
+            <a:off x="5202936" y="3547872"/>
+            <a:ext cx="1764792" cy="548640"/>
           </a:xfrm>
           <a:prstGeom prst="rect">
             <a:avLst/>
@@ -35140,13 +35169,13 @@
           <a:p>
             <a:pPr algn="l"/>
             <a:r>
-              <a:rPr sz="1350" b="1" i="0">
+              <a:rPr sz="1250" b="1" i="0">
                 <a:solidFill>
                   <a:srgbClr val="061F79"/>
                 </a:solidFill>
                 <a:latin typeface="Arial"/>
               </a:rPr>
-              <a:t>Platform org of the future</a:t>
+              <a:t>Future-ready workforce</a:t>
             </a:r>
           </a:p>
         </p:txBody>
@@ -35159,8 +35188,8 @@
         </p:nvSpPr>
         <p:spPr>
           <a:xfrm>
-            <a:off x="2939796" y="4334256"/>
-            <a:ext cx="1847088" cy="685800"/>
+            <a:off x="5202936" y="4114800"/>
+            <a:ext cx="1764792" cy="566928"/>
           </a:xfrm>
           <a:prstGeom prst="rect">
             <a:avLst/>
@@ -35175,13 +35204,13 @@
           <a:p>
             <a:pPr algn="l"/>
             <a:r>
-              <a:rPr sz="1150" b="0" i="0">
+              <a:rPr sz="1050" b="0" i="0">
                 <a:solidFill>
                   <a:srgbClr val="000000"/>
                 </a:solidFill>
                 <a:latin typeface="Arial"/>
               </a:rPr>
-              <a:t>Structure for the platform era, not the product era</a:t>
+              <a:t>The AI-era workforce, with AI-ready skills</a:t>
             </a:r>
           </a:p>
         </p:txBody>
@@ -35194,12 +35223,12 @@
         </p:nvSpPr>
         <p:spPr>
           <a:xfrm>
-            <a:off x="5029200" y="3529584"/>
-            <a:ext cx="2139696" cy="1572768"/>
+            <a:off x="7200900" y="3364991"/>
+            <a:ext cx="2020824" cy="1389888"/>
           </a:xfrm>
           <a:prstGeom prst="roundRect">
             <a:avLst>
-              <a:gd name="adj" fmla="val 8000"/>
+              <a:gd name="adj" fmla="val 9000"/>
             </a:avLst>
           </a:prstGeom>
           <a:solidFill>
@@ -35242,8 +35271,8 @@
         </p:nvSpPr>
         <p:spPr>
           <a:xfrm>
-            <a:off x="5010912" y="3410712"/>
-            <a:ext cx="274320" cy="274320"/>
+            <a:off x="7182612" y="3246120"/>
+            <a:ext cx="256032" cy="256032"/>
           </a:xfrm>
           <a:prstGeom prst="ellipse">
             <a:avLst/>
@@ -35276,13 +35305,13 @@
           <a:p>
             <a:pPr algn="ctr"/>
             <a:r>
-              <a:rPr sz="1200" b="1">
+              <a:rPr sz="1100" b="1">
                 <a:solidFill>
                   <a:srgbClr val="FFFFFF"/>
                 </a:solidFill>
                 <a:latin typeface="Arial"/>
               </a:rPr>
-              <a:t>3</a:t>
+              <a:t>4</a:t>
             </a:r>
           </a:p>
         </p:txBody>
@@ -35295,8 +35324,8 @@
         </p:nvSpPr>
         <p:spPr>
           <a:xfrm>
-            <a:off x="5175504" y="3749039"/>
-            <a:ext cx="1847088" cy="566928"/>
+            <a:off x="7328916" y="3547872"/>
+            <a:ext cx="1764792" cy="548640"/>
           </a:xfrm>
           <a:prstGeom prst="rect">
             <a:avLst/>
@@ -35311,13 +35340,13 @@
           <a:p>
             <a:pPr algn="l"/>
             <a:r>
-              <a:rPr sz="1350" b="1" i="0">
+              <a:rPr sz="1250" b="1" i="0">
                 <a:solidFill>
                   <a:srgbClr val="061F79"/>
                 </a:solidFill>
                 <a:latin typeface="Arial"/>
               </a:rPr>
-              <a:t>Future-ready workforce</a:t>
+              <a:t>Global location strategy</a:t>
             </a:r>
           </a:p>
         </p:txBody>
@@ -35330,8 +35359,8 @@
         </p:nvSpPr>
         <p:spPr>
           <a:xfrm>
-            <a:off x="5175504" y="4334256"/>
-            <a:ext cx="1847088" cy="685800"/>
+            <a:off x="7328916" y="4114800"/>
+            <a:ext cx="1764792" cy="566928"/>
           </a:xfrm>
           <a:prstGeom prst="rect">
             <a:avLst/>
@@ -35346,13 +35375,13 @@
           <a:p>
             <a:pPr algn="l"/>
             <a:r>
-              <a:rPr sz="1150" b="0" i="0">
+              <a:rPr sz="1050" b="0" i="0">
                 <a:solidFill>
                   <a:srgbClr val="000000"/>
                 </a:solidFill>
                 <a:latin typeface="Arial"/>
               </a:rPr>
-              <a:t>The AI-era workforce, with AI-ready skills</a:t>
+              <a:t>The footprint for the future workforce</a:t>
             </a:r>
           </a:p>
         </p:txBody>
@@ -35365,12 +35394,12 @@
         </p:nvSpPr>
         <p:spPr>
           <a:xfrm>
-            <a:off x="7264907" y="3529584"/>
-            <a:ext cx="2139696" cy="1572768"/>
+            <a:off x="9326880" y="3364991"/>
+            <a:ext cx="2020824" cy="1389888"/>
           </a:xfrm>
           <a:prstGeom prst="roundRect">
             <a:avLst>
-              <a:gd name="adj" fmla="val 8000"/>
+              <a:gd name="adj" fmla="val 9000"/>
             </a:avLst>
           </a:prstGeom>
           <a:solidFill>
@@ -35413,8 +35442,8 @@
         </p:nvSpPr>
         <p:spPr>
           <a:xfrm>
-            <a:off x="7246620" y="3410712"/>
-            <a:ext cx="274320" cy="274320"/>
+            <a:off x="9308592" y="3246120"/>
+            <a:ext cx="256032" cy="256032"/>
           </a:xfrm>
           <a:prstGeom prst="ellipse">
             <a:avLst/>
@@ -35447,13 +35476,13 @@
           <a:p>
             <a:pPr algn="ctr"/>
             <a:r>
-              <a:rPr sz="1200" b="1">
+              <a:rPr sz="1100" b="1">
                 <a:solidFill>
                   <a:srgbClr val="FFFFFF"/>
                 </a:solidFill>
                 <a:latin typeface="Arial"/>
               </a:rPr>
-              <a:t>4</a:t>
+              <a:t>5</a:t>
             </a:r>
           </a:p>
         </p:txBody>
@@ -35466,8 +35495,8 @@
         </p:nvSpPr>
         <p:spPr>
           <a:xfrm>
-            <a:off x="7411211" y="3749039"/>
-            <a:ext cx="1847088" cy="566928"/>
+            <a:off x="9454896" y="3547872"/>
+            <a:ext cx="1764792" cy="548640"/>
           </a:xfrm>
           <a:prstGeom prst="rect">
             <a:avLst/>
@@ -35482,13 +35511,13 @@
           <a:p>
             <a:pPr algn="l"/>
             <a:r>
-              <a:rPr sz="1350" b="1" i="0">
+              <a:rPr sz="1250" b="1" i="0">
                 <a:solidFill>
                   <a:srgbClr val="061F79"/>
                 </a:solidFill>
                 <a:latin typeface="Arial"/>
               </a:rPr>
-              <a:t>Global location strategy</a:t>
+              <a:t>Culture</a:t>
             </a:r>
           </a:p>
         </p:txBody>
@@ -35501,8 +35530,8 @@
         </p:nvSpPr>
         <p:spPr>
           <a:xfrm>
-            <a:off x="7411211" y="4334256"/>
-            <a:ext cx="1847088" cy="685800"/>
+            <a:off x="9454896" y="4114800"/>
+            <a:ext cx="1764792" cy="566928"/>
           </a:xfrm>
           <a:prstGeom prst="rect">
             <a:avLst/>
@@ -35517,13 +35546,13 @@
           <a:p>
             <a:pPr algn="l"/>
             <a:r>
-              <a:rPr sz="1150" b="0" i="0">
+              <a:rPr sz="1050" b="0" i="0">
                 <a:solidFill>
                   <a:srgbClr val="000000"/>
                 </a:solidFill>
                 <a:latin typeface="Arial"/>
               </a:rPr>
-              <a:t>The footprint for the future workforce</a:t>
+              <a:t>The mindset and behavior shifts to make it work</a:t>
             </a:r>
           </a:p>
         </p:txBody>
@@ -35536,178 +35565,7 @@
         </p:nvSpPr>
         <p:spPr>
           <a:xfrm>
-            <a:off x="9500615" y="3529584"/>
-            <a:ext cx="2139696" cy="1572768"/>
-          </a:xfrm>
-          <a:prstGeom prst="roundRect">
-            <a:avLst>
-              <a:gd name="adj" fmla="val 8000"/>
-            </a:avLst>
-          </a:prstGeom>
-          <a:solidFill>
-            <a:srgbClr val="FFFFFF"/>
-          </a:solidFill>
-          <a:ln w="12700">
-            <a:solidFill>
-              <a:srgbClr val="2251FF"/>
-            </a:solidFill>
-          </a:ln>
-          <a:effectLst/>
-        </p:spPr>
-        <p:style>
-          <a:lnRef idx="1">
-            <a:schemeClr val="accent1"/>
-          </a:lnRef>
-          <a:fillRef idx="3">
-            <a:schemeClr val="accent1"/>
-          </a:fillRef>
-          <a:effectRef idx="2">
-            <a:schemeClr val="accent1"/>
-          </a:effectRef>
-          <a:fontRef idx="minor">
-            <a:schemeClr val="lt1"/>
-          </a:fontRef>
-        </p:style>
-        <p:txBody>
-          <a:bodyPr rtlCol="0" anchor="ctr"/>
-          <a:lstStyle/>
-          <a:p>
-            <a:pPr algn="ctr"/>
-          </a:p>
-        </p:txBody>
-      </p:sp>
-      <p:sp>
-        <p:nvSpPr>
-          <p:cNvPr id="27" name="Oval 26"/>
-          <p:cNvSpPr/>
-          <p:nvPr/>
-        </p:nvSpPr>
-        <p:spPr>
-          <a:xfrm>
-            <a:off x="9482328" y="3410712"/>
-            <a:ext cx="274320" cy="274320"/>
-          </a:xfrm>
-          <a:prstGeom prst="ellipse">
-            <a:avLst/>
-          </a:prstGeom>
-          <a:solidFill>
-            <a:srgbClr val="2251FF"/>
-          </a:solidFill>
-          <a:ln>
-            <a:noFill/>
-          </a:ln>
-          <a:effectLst/>
-        </p:spPr>
-        <p:style>
-          <a:lnRef idx="1">
-            <a:schemeClr val="accent1"/>
-          </a:lnRef>
-          <a:fillRef idx="3">
-            <a:schemeClr val="accent1"/>
-          </a:fillRef>
-          <a:effectRef idx="2">
-            <a:schemeClr val="accent1"/>
-          </a:effectRef>
-          <a:fontRef idx="minor">
-            <a:schemeClr val="lt1"/>
-          </a:fontRef>
-        </p:style>
-        <p:txBody>
-          <a:bodyPr rtlCol="0" anchor="ctr" lIns="0" rIns="0" tIns="0" bIns="0" wrap="none"/>
-          <a:lstStyle/>
-          <a:p>
-            <a:pPr algn="ctr"/>
-            <a:r>
-              <a:rPr sz="1200" b="1">
-                <a:solidFill>
-                  <a:srgbClr val="FFFFFF"/>
-                </a:solidFill>
-                <a:latin typeface="Arial"/>
-              </a:rPr>
-              <a:t>5</a:t>
-            </a:r>
-          </a:p>
-        </p:txBody>
-      </p:sp>
-      <p:sp>
-        <p:nvSpPr>
-          <p:cNvPr id="28" name="TextBox 27"/>
-          <p:cNvSpPr txBox="1"/>
-          <p:nvPr/>
-        </p:nvSpPr>
-        <p:spPr>
-          <a:xfrm>
-            <a:off x="9646919" y="3749039"/>
-            <a:ext cx="1847088" cy="566928"/>
-          </a:xfrm>
-          <a:prstGeom prst="rect">
-            <a:avLst/>
-          </a:prstGeom>
-          <a:noFill/>
-        </p:spPr>
-        <p:txBody>
-          <a:bodyPr wrap="square" anchor="t" lIns="0" rIns="0" tIns="0" bIns="0">
-            <a:spAutoFit/>
-          </a:bodyPr>
-          <a:lstStyle/>
-          <a:p>
-            <a:pPr algn="l"/>
-            <a:r>
-              <a:rPr sz="1350" b="1" i="0">
-                <a:solidFill>
-                  <a:srgbClr val="061F79"/>
-                </a:solidFill>
-                <a:latin typeface="Arial"/>
-              </a:rPr>
-              <a:t>Culture</a:t>
-            </a:r>
-          </a:p>
-        </p:txBody>
-      </p:sp>
-      <p:sp>
-        <p:nvSpPr>
-          <p:cNvPr id="29" name="TextBox 28"/>
-          <p:cNvSpPr txBox="1"/>
-          <p:nvPr/>
-        </p:nvSpPr>
-        <p:spPr>
-          <a:xfrm>
-            <a:off x="9646919" y="4334256"/>
-            <a:ext cx="1847088" cy="685800"/>
-          </a:xfrm>
-          <a:prstGeom prst="rect">
-            <a:avLst/>
-          </a:prstGeom>
-          <a:noFill/>
-        </p:spPr>
-        <p:txBody>
-          <a:bodyPr wrap="square" anchor="t" lIns="0" rIns="0" tIns="0" bIns="0">
-            <a:spAutoFit/>
-          </a:bodyPr>
-          <a:lstStyle/>
-          <a:p>
-            <a:pPr algn="l"/>
-            <a:r>
-              <a:rPr sz="1150" b="0" i="0">
-                <a:solidFill>
-                  <a:srgbClr val="000000"/>
-                </a:solidFill>
-                <a:latin typeface="Arial"/>
-              </a:rPr>
-              <a:t>The mindset and behavior shifts to make it work</a:t>
-            </a:r>
-          </a:p>
-        </p:txBody>
-      </p:sp>
-      <p:sp>
-        <p:nvSpPr>
-          <p:cNvPr id="30" name="Rounded Rectangle 29"/>
-          <p:cNvSpPr/>
-          <p:nvPr/>
-        </p:nvSpPr>
-        <p:spPr>
-          <a:xfrm>
-            <a:off x="557784" y="5532120"/>
+            <a:off x="557784" y="5349240"/>
             <a:ext cx="11082528" cy="841248"/>
           </a:xfrm>
           <a:prstGeom prst="roundRect">
@@ -35747,13 +35605,13 @@
       </p:sp>
       <p:sp>
         <p:nvSpPr>
-          <p:cNvPr id="31" name="TextBox 30"/>
+          <p:cNvPr id="27" name="TextBox 26"/>
           <p:cNvSpPr txBox="1"/>
           <p:nvPr/>
         </p:nvSpPr>
         <p:spPr>
           <a:xfrm>
-            <a:off x="868680" y="5641848"/>
+            <a:off x="868680" y="5458968"/>
             <a:ext cx="10469880" cy="621792"/>
           </a:xfrm>
           <a:prstGeom prst="rect">
@@ -35797,7 +35655,42 @@
                 </a:solidFill>
                 <a:latin typeface="Arial"/>
               </a:rPr>
-              <a:t>Today — align on the questions to answer, and a ~3-month program to answer them</a:t>
+              <a:t>Today — align on the questions each track must answer, and the shape of a ~3-month program</a:t>
+            </a:r>
+          </a:p>
+        </p:txBody>
+      </p:sp>
+      <p:sp>
+        <p:nvSpPr>
+          <p:cNvPr id="28" name="TextBox 27"/>
+          <p:cNvSpPr txBox="1"/>
+          <p:nvPr/>
+        </p:nvSpPr>
+        <p:spPr>
+          <a:xfrm>
+            <a:off x="557784" y="6291072"/>
+            <a:ext cx="11082528" cy="164592"/>
+          </a:xfrm>
+          <a:prstGeom prst="rect">
+            <a:avLst/>
+          </a:prstGeom>
+          <a:noFill/>
+        </p:spPr>
+        <p:txBody>
+          <a:bodyPr wrap="square" anchor="t" lIns="0" rIns="0" tIns="0" bIns="0">
+            <a:spAutoFit/>
+          </a:bodyPr>
+          <a:lstStyle/>
+          <a:p>
+            <a:pPr algn="l"/>
+            <a:r>
+              <a:rPr sz="850" b="0" i="0">
+                <a:solidFill>
+                  <a:srgbClr val="63666A"/>
+                </a:solidFill>
+                <a:latin typeface="Arial"/>
+              </a:rPr>
+              <a:t>1. McKinsey cross-industry experience — share of AI-addressable value typically concentrated in a small number of cross-functional domains</a:t>
             </a:r>
           </a:p>
         </p:txBody>
@@ -36044,7 +35937,7 @@
         </p:nvSpPr>
         <p:spPr>
           <a:xfrm>
-            <a:off x="557784" y="2720340"/>
+            <a:off x="557784" y="2848356"/>
             <a:ext cx="256032" cy="256032"/>
           </a:xfrm>
           <a:prstGeom prst="ellipse">
@@ -36097,7 +35990,7 @@
         </p:nvSpPr>
         <p:spPr>
           <a:xfrm>
-            <a:off x="941832" y="2711196"/>
+            <a:off x="941832" y="2839212"/>
             <a:ext cx="3776472" cy="868680"/>
           </a:xfrm>
           <a:prstGeom prst="rect">
@@ -36145,7 +36038,7 @@
         </p:nvSpPr>
         <p:spPr>
           <a:xfrm>
-            <a:off x="557784" y="3630168"/>
+            <a:off x="557784" y="3886200"/>
             <a:ext cx="256032" cy="256032"/>
           </a:xfrm>
           <a:prstGeom prst="ellipse">
@@ -36198,7 +36091,7 @@
         </p:nvSpPr>
         <p:spPr>
           <a:xfrm>
-            <a:off x="941832" y="3621024"/>
+            <a:off x="941832" y="3877056"/>
             <a:ext cx="3776472" cy="868680"/>
           </a:xfrm>
           <a:prstGeom prst="rect">
@@ -36246,7 +36139,7 @@
         </p:nvSpPr>
         <p:spPr>
           <a:xfrm>
-            <a:off x="557784" y="4539996"/>
+            <a:off x="557784" y="4924044"/>
             <a:ext cx="256032" cy="256032"/>
           </a:xfrm>
           <a:prstGeom prst="ellipse">
@@ -36299,7 +36192,7 @@
         </p:nvSpPr>
         <p:spPr>
           <a:xfrm>
-            <a:off x="941832" y="4530852"/>
+            <a:off x="941832" y="4914900"/>
             <a:ext cx="3776472" cy="868680"/>
           </a:xfrm>
           <a:prstGeom prst="rect">
@@ -36347,7 +36240,7 @@
         </p:nvSpPr>
         <p:spPr>
           <a:xfrm>
-            <a:off x="557784" y="5225796"/>
+            <a:off x="557784" y="5737859"/>
             <a:ext cx="256032" cy="256032"/>
           </a:xfrm>
           <a:prstGeom prst="ellipse">
@@ -36400,7 +36293,7 @@
         </p:nvSpPr>
         <p:spPr>
           <a:xfrm>
-            <a:off x="941832" y="5216652"/>
+            <a:off x="941832" y="5728716"/>
             <a:ext cx="3776472" cy="868680"/>
           </a:xfrm>
           <a:prstGeom prst="rect">
@@ -36683,7 +36576,7 @@
                 </a:solidFill>
                 <a:latin typeface="Arial"/>
               </a:rPr>
-              <a:t>Where does the structure deviate most from benchmark — and what value is at stake?</a:t>
+              <a:t>Where does the structure deviate most from benchmark, and what value is at stake?</a:t>
             </a:r>
           </a:p>
         </p:txBody>
@@ -36696,7 +36589,7 @@
         </p:nvSpPr>
         <p:spPr>
           <a:xfrm>
-            <a:off x="5074920" y="3922776"/>
+            <a:off x="5074920" y="3886200"/>
             <a:ext cx="3145536" cy="219456"/>
           </a:xfrm>
           <a:prstGeom prst="rect">
@@ -36731,7 +36624,7 @@
         </p:nvCxnSpPr>
         <p:spPr>
           <a:xfrm>
-            <a:off x="5074920" y="4197096"/>
+            <a:off x="5074920" y="4160520"/>
             <a:ext cx="3145536" cy="0"/>
           </a:xfrm>
           <a:prstGeom prst="line">
@@ -36767,7 +36660,7 @@
         </p:nvSpPr>
         <p:spPr>
           <a:xfrm>
-            <a:off x="5074920" y="4306824"/>
+            <a:off x="5074920" y="4270248"/>
             <a:ext cx="3145536" cy="731520"/>
           </a:xfrm>
           <a:prstGeom prst="rect">
@@ -36802,7 +36695,7 @@
                 </a:solidFill>
                 <a:latin typeface="Arial"/>
               </a:rPr>
-              <a:t>What can TU learn from genuine platform orgs (e.g., Adobe) vs. GM-model operators (e.g., Amazon, Google) — and which model fits?</a:t>
+              <a:t>What can TU learn from genuine platform orgs (e.g., Adobe) vs. general-manager-led models (e.g., Amazon, Google) — and which fits TU?</a:t>
             </a:r>
           </a:p>
         </p:txBody>
@@ -36815,7 +36708,7 @@
         </p:nvSpPr>
         <p:spPr>
           <a:xfrm>
-            <a:off x="5074920" y="5294376"/>
+            <a:off x="5074920" y="5257800"/>
             <a:ext cx="3145536" cy="731520"/>
           </a:xfrm>
           <a:prstGeom prst="rect">
@@ -36850,7 +36743,7 @@
                 </a:solidFill>
                 <a:latin typeface="Arial"/>
               </a:rPr>
-              <a:t>What are the core design choices — US vs. intl P&amp;L, regional vs. global layers, where technologists sit — and what must TU believe?</a:t>
+              <a:t>What are the core design choices — US vs. international P&amp;L, regional vs. global layers, where technologists sit — and what must TU believe?</a:t>
             </a:r>
           </a:p>
         </p:txBody>
@@ -37078,7 +36971,7 @@
         </p:nvSpPr>
         <p:spPr>
           <a:xfrm>
-            <a:off x="8494776" y="4265676"/>
+            <a:off x="8494776" y="4229100"/>
             <a:ext cx="3145536" cy="219456"/>
           </a:xfrm>
           <a:prstGeom prst="rect">
@@ -37100,7 +36993,7 @@
                 </a:solidFill>
                 <a:latin typeface="Arial"/>
               </a:rPr>
-              <a:t>GLOBAL LOCATION STRATEGY</a:t>
+              <a:t>GLOBAL LOCATION STRATEGY (GLS 2.0)</a:t>
             </a:r>
           </a:p>
         </p:txBody>
@@ -37113,7 +37006,7 @@
         </p:nvCxnSpPr>
         <p:spPr>
           <a:xfrm>
-            <a:off x="8494776" y="4539996"/>
+            <a:off x="8494776" y="4503420"/>
             <a:ext cx="3145535" cy="0"/>
           </a:xfrm>
           <a:prstGeom prst="line">
@@ -37149,7 +37042,7 @@
         </p:nvSpPr>
         <p:spPr>
           <a:xfrm>
-            <a:off x="8494776" y="4649724"/>
+            <a:off x="8494776" y="4613148"/>
             <a:ext cx="3145536" cy="731520"/>
           </a:xfrm>
           <a:prstGeom prst="rect">
@@ -37184,7 +37077,7 @@
                 </a:solidFill>
                 <a:latin typeface="Arial"/>
               </a:rPr>
-              <a:t>Which roles sit where (GLS 2.0) — and what moves now vs. later?</a:t>
+              <a:t>Which roles sit where under a refreshed GLS 2.0, and what moves now vs. later?</a:t>
             </a:r>
           </a:p>
         </p:txBody>
@@ -37197,7 +37090,7 @@
         </p:nvSpPr>
         <p:spPr>
           <a:xfrm>
-            <a:off x="8494776" y="5390388"/>
+            <a:off x="8494776" y="5317236"/>
             <a:ext cx="3145536" cy="219456"/>
           </a:xfrm>
           <a:prstGeom prst="rect">
@@ -37232,7 +37125,7 @@
         </p:nvCxnSpPr>
         <p:spPr>
           <a:xfrm>
-            <a:off x="8494776" y="5664708"/>
+            <a:off x="8494776" y="5591556"/>
             <a:ext cx="3145535" cy="0"/>
           </a:xfrm>
           <a:prstGeom prst="line">
@@ -37268,7 +37161,7 @@
         </p:nvSpPr>
         <p:spPr>
           <a:xfrm>
-            <a:off x="8494776" y="5774436"/>
+            <a:off x="8494776" y="5701284"/>
             <a:ext cx="3145536" cy="731520"/>
           </a:xfrm>
           <a:prstGeom prst="rect">
@@ -37303,7 +37196,7 @@
                 </a:solidFill>
                 <a:latin typeface="Arial"/>
               </a:rPr>
-              <a:t>What mindset and behavior shifts are needed — and is there change capacity to absorb them?</a:t>
+              <a:t>What mindset and behavior shifts are needed — and can TU absorb the change?</a:t>
             </a:r>
           </a:p>
         </p:txBody>
@@ -37355,7 +37248,7 @@
                   <a:srgbClr val="000000"/>
                 </a:solidFill>
               </a:rPr>
-              <a:t>building blocks and indicative timeline across the two tracks</a:t>
+              <a:t>building blocks across the two tracks</a:t>
             </a:r>
           </a:p>
         </p:txBody>
@@ -38955,7 +38848,7 @@
                 </a:solidFill>
                 <a:latin typeface="Arial"/>
               </a:rPr>
-              <a:t>→ 12–14-week lighthouse initiatives in the priority domains</a:t>
+              <a:t>→ Lighthouse pilots in the priority domains — start Wk 9, run 12–14 weeks</a:t>
             </a:r>
           </a:p>
         </p:txBody>
@@ -39425,7 +39318,7 @@
                 </a:solidFill>
                 <a:latin typeface="Arial"/>
               </a:rPr>
-              <a:t>Location footprint (GLS 2.0 refresh)</a:t>
+              <a:t>Location footprint refresh (GLS 2.0)</a:t>
             </a:r>
           </a:p>
         </p:txBody>
@@ -39523,8 +39416,8 @@
         </p:nvSpPr>
         <p:spPr>
           <a:xfrm>
-            <a:off x="557784" y="5047488"/>
-            <a:ext cx="7315200" cy="182880"/>
+            <a:off x="557784" y="4974336"/>
+            <a:ext cx="7315200" cy="164592"/>
           </a:xfrm>
           <a:prstGeom prst="rect">
             <a:avLst/>
@@ -39552,14 +39445,74 @@
       </p:sp>
       <p:sp>
         <p:nvSpPr>
-          <p:cNvPr id="60" name="Rounded Rectangle 59"/>
+          <p:cNvPr id="60" name="TextBox 59"/>
+          <p:cNvSpPr txBox="1"/>
+          <p:nvPr/>
+        </p:nvSpPr>
+        <p:spPr>
+          <a:xfrm>
+            <a:off x="557784" y="5175504"/>
+            <a:ext cx="11082528" cy="310896"/>
+          </a:xfrm>
+          <a:prstGeom prst="rect">
+            <a:avLst/>
+          </a:prstGeom>
+          <a:noFill/>
+        </p:spPr>
+        <p:txBody>
+          <a:bodyPr wrap="square" anchor="t" lIns="0" rIns="0" tIns="0" bIns="0">
+            <a:spAutoFit/>
+          </a:bodyPr>
+          <a:lstStyle/>
+          <a:p>
+            <a:pPr algn="l"/>
+            <a:r>
+              <a:rPr sz="1050" b="1" i="0">
+                <a:solidFill>
+                  <a:srgbClr val="061F79"/>
+                </a:solidFill>
+                <a:latin typeface="Arial"/>
+              </a:rPr>
+              <a:t>By week 12:  </a:t>
+            </a:r>
+            <a:r>
+              <a:rPr sz="1050" b="0" i="0">
+                <a:solidFill>
+                  <a:srgbClr val="000000"/>
+                </a:solidFill>
+                <a:latin typeface="Arial"/>
+              </a:rPr>
+              <a:t>prioritized domain portfolio and value-backed roadmap  ·  target org blueprint and strategic workforce plan  ·  location and talent roadmap, with a 90-day mobilization plan</a:t>
+            </a:r>
+          </a:p>
+          <a:p>
+            <a:pPr algn="l">
+              <a:spcBef>
+                <a:spcPts val="300"/>
+              </a:spcBef>
+            </a:pPr>
+            <a:r>
+              <a:rPr sz="1050" b="0" i="0">
+                <a:solidFill>
+                  <a:srgbClr val="63666A"/>
+                </a:solidFill>
+                <a:latin typeface="Arial"/>
+              </a:rPr>
+              <a:t>Joint TU–McKinsey team; leadership checkpoints at weeks 2, 7, and 12</a:t>
+            </a:r>
+          </a:p>
+        </p:txBody>
+      </p:sp>
+      <p:sp>
+        <p:nvSpPr>
+          <p:cNvPr id="61" name="Rounded Rectangle 60"/>
           <p:cNvSpPr/>
           <p:nvPr/>
         </p:nvSpPr>
         <p:spPr>
           <a:xfrm>
-            <a:off x="557784" y="5394960"/>
-            <a:ext cx="11082528" cy="868680"/>
+            <a:off x="557784" y="5596128"/>
+            <a:ext cx="11082528" cy="777240"/>
           </a:xfrm>
           <a:prstGeom prst="roundRect">
             <a:avLst>
@@ -39598,58 +39551,14 @@
       </p:sp>
       <p:sp>
         <p:nvSpPr>
-          <p:cNvPr id="61" name="Circular Arrow 60"/>
-          <p:cNvSpPr/>
-          <p:nvPr/>
-        </p:nvSpPr>
-        <p:spPr>
-          <a:xfrm>
-            <a:off x="822960" y="5596128"/>
-            <a:ext cx="475488" cy="475488"/>
-          </a:xfrm>
-          <a:prstGeom prst="circularArrow">
-            <a:avLst/>
-          </a:prstGeom>
-          <a:solidFill>
-            <a:srgbClr val="2251FF"/>
-          </a:solidFill>
-          <a:ln>
-            <a:noFill/>
-          </a:ln>
-          <a:effectLst/>
-        </p:spPr>
-        <p:style>
-          <a:lnRef idx="1">
-            <a:schemeClr val="accent1"/>
-          </a:lnRef>
-          <a:fillRef idx="3">
-            <a:schemeClr val="accent1"/>
-          </a:fillRef>
-          <a:effectRef idx="2">
-            <a:schemeClr val="accent1"/>
-          </a:effectRef>
-          <a:fontRef idx="minor">
-            <a:schemeClr val="lt1"/>
-          </a:fontRef>
-        </p:style>
-        <p:txBody>
-          <a:bodyPr rtlCol="0" anchor="ctr"/>
-          <a:lstStyle/>
-          <a:p>
-            <a:pPr algn="ctr"/>
-          </a:p>
-        </p:txBody>
-      </p:sp>
-      <p:sp>
-        <p:nvSpPr>
           <p:cNvPr id="62" name="TextBox 61"/>
           <p:cNvSpPr txBox="1"/>
           <p:nvPr/>
         </p:nvSpPr>
         <p:spPr>
           <a:xfrm>
-            <a:off x="1508760" y="5486400"/>
-            <a:ext cx="9921240" cy="713232"/>
+            <a:off x="868680" y="5678424"/>
+            <a:ext cx="10469880" cy="621792"/>
           </a:xfrm>
           <a:prstGeom prst="rect">
             <a:avLst/>
@@ -39674,7 +39583,7 @@
                 </a:solidFill>
                 <a:latin typeface="Arial"/>
               </a:rPr>
-              <a:t>The tracks feed each other:  </a:t>
+              <a:t>The two tracks feed each other:  </a:t>
             </a:r>
             <a:r>
               <a:rPr sz="1250" b="0" i="0">
@@ -39683,7 +39592,7 @@
                 </a:solidFill>
                 <a:latin typeface="Arial"/>
               </a:rPr>
-              <a:t>domain transformation reconfigures teams bottom-up — new role mixes, shapes, and skills; learnings flow into the top-down workforce plan, which steers where talent, skills, and locations flex next — </a:t>
+              <a:t>the enterprise picks its domains top-down; transformation then reconfigures teams bottom-up — new role mixes, team shapes, and skills — and </a:t>
             </a:r>
             <a:r>
               <a:rPr sz="1250" b="1" i="0">
@@ -39692,7 +39601,7 @@
                 </a:solidFill>
                 <a:latin typeface="Arial"/>
               </a:rPr>
-              <a:t>a continuous rhythm of learning, investment, and reallocation</a:t>
+              <a:t>those learnings reset the top-down workforce plan on a regular cadence</a:t>
             </a:r>
           </a:p>
         </p:txBody>

</xml_diff>

<commit_message>
Restore dictated setup beat as page 2 opening
Setup line (platform evolution + early AI journey) now opens the page;
the flip applies only to the order of the two tracks beneath it.

Co-Authored-By: Claude Fable 5 <noreply@anthropic.com>
Claude-Session: https://claude.ai/code/session_01A3Z3HHfQP1XqLkWjeuhpsJ
</commit_message>
<xml_diff>
--- a/proposal/TU_Org_AI_3pager_vDraft.pptx
+++ b/proposal/TU_Org_AI_3pager_vDraft.pptx
@@ -34497,6 +34497,81 @@
         <p:spPr>
           <a:xfrm>
             <a:off x="557784" y="1188720"/>
+            <a:ext cx="11082528" cy="502920"/>
+          </a:xfrm>
+          <a:prstGeom prst="rect">
+            <a:avLst/>
+          </a:prstGeom>
+          <a:noFill/>
+        </p:spPr>
+        <p:txBody>
+          <a:bodyPr wrap="square" anchor="t" lIns="0" rIns="0" tIns="0" bIns="0">
+            <a:spAutoFit/>
+          </a:bodyPr>
+          <a:lstStyle/>
+          <a:p>
+            <a:pPr algn="l">
+              <a:lnSpc>
+                <a:spcPct val="108000"/>
+              </a:lnSpc>
+            </a:pPr>
+            <a:r>
+              <a:rPr sz="1350" b="0" i="0">
+                <a:solidFill>
+                  <a:srgbClr val="000000"/>
+                </a:solidFill>
+                <a:latin typeface="Arial"/>
+              </a:rPr>
+              <a:t>TU has evolved from credit bureau, to product company, to </a:t>
+            </a:r>
+            <a:r>
+              <a:rPr sz="1350" b="1" i="0">
+                <a:solidFill>
+                  <a:srgbClr val="000000"/>
+                </a:solidFill>
+                <a:latin typeface="Arial"/>
+              </a:rPr>
+              <a:t>platform organization — thin products on thick platforms</a:t>
+            </a:r>
+            <a:r>
+              <a:rPr sz="1350" b="0" i="0">
+                <a:solidFill>
+                  <a:srgbClr val="000000"/>
+                </a:solidFill>
+                <a:latin typeface="Arial"/>
+              </a:rPr>
+              <a:t> — and it has embarked on its AI journey, </a:t>
+            </a:r>
+            <a:r>
+              <a:rPr sz="1350" b="1" i="0">
+                <a:solidFill>
+                  <a:srgbClr val="000000"/>
+                </a:solidFill>
+                <a:latin typeface="Arial"/>
+              </a:rPr>
+              <a:t>albeit still early</a:t>
+            </a:r>
+            <a:r>
+              <a:rPr sz="1350" b="0" i="0">
+                <a:solidFill>
+                  <a:srgbClr val="000000"/>
+                </a:solidFill>
+                <a:latin typeface="Arial"/>
+              </a:rPr>
+              <a:t>. Two journeys follow:</a:t>
+            </a:r>
+          </a:p>
+        </p:txBody>
+      </p:sp>
+      <p:sp>
+        <p:nvSpPr>
+          <p:cNvPr id="4" name="TextBox 3"/>
+          <p:cNvSpPr txBox="1"/>
+          <p:nvPr/>
+        </p:nvSpPr>
+        <p:spPr>
+          <a:xfrm>
+            <a:off x="557784" y="1847088"/>
             <a:ext cx="11082528" cy="777240"/>
           </a:xfrm>
           <a:prstGeom prst="rect">
@@ -34574,14 +34649,14 @@
       </p:sp>
       <p:sp>
         <p:nvSpPr>
-          <p:cNvPr id="4" name="Rounded Rectangle 3"/>
+          <p:cNvPr id="5" name="Rounded Rectangle 4"/>
           <p:cNvSpPr/>
           <p:nvPr/>
         </p:nvSpPr>
         <p:spPr>
           <a:xfrm>
-            <a:off x="557784" y="2212848"/>
-            <a:ext cx="11082528" cy="2761488"/>
+            <a:off x="557784" y="2633472"/>
+            <a:ext cx="11082528" cy="2377440"/>
           </a:xfrm>
           <a:prstGeom prst="roundRect">
             <a:avLst>
@@ -34620,14 +34695,14 @@
       </p:sp>
       <p:sp>
         <p:nvSpPr>
-          <p:cNvPr id="5" name="TextBox 4"/>
+          <p:cNvPr id="6" name="TextBox 5"/>
           <p:cNvSpPr txBox="1"/>
           <p:nvPr/>
         </p:nvSpPr>
         <p:spPr>
           <a:xfrm>
-            <a:off x="822960" y="2359152"/>
-            <a:ext cx="10561320" cy="731520"/>
+            <a:off x="822960" y="2761488"/>
+            <a:ext cx="10561320" cy="566928"/>
           </a:xfrm>
           <a:prstGeom prst="rect">
             <a:avLst/>
@@ -34661,25 +34736,7 @@
                 </a:solidFill>
                 <a:latin typeface="Arial"/>
               </a:rPr>
-              <a:t> It has evolved from credit bureau, to product company, to platform organization — </a:t>
-            </a:r>
-            <a:r>
-              <a:rPr sz="1350" b="1" i="0">
-                <a:solidFill>
-                  <a:srgbClr val="000000"/>
-                </a:solidFill>
-                <a:latin typeface="Arial"/>
-              </a:rPr>
-              <a:t>thin products on thick platforms</a:t>
-            </a:r>
-            <a:r>
-              <a:rPr sz="1350" b="0" i="0">
-                <a:solidFill>
-                  <a:srgbClr val="000000"/>
-                </a:solidFill>
-                <a:latin typeface="Arial"/>
-              </a:rPr>
-              <a:t> — while still early in its AI journey. In leadership's own framing: </a:t>
+              <a:t> Its structure has not kept pace with what it is becoming — in leadership's own framing, </a:t>
             </a:r>
             <a:r>
               <a:rPr sz="1350" b="1" i="1">
@@ -34704,13 +34761,13 @@
       </p:sp>
       <p:sp>
         <p:nvSpPr>
-          <p:cNvPr id="6" name="Rounded Rectangle 5"/>
+          <p:cNvPr id="7" name="Rounded Rectangle 6"/>
           <p:cNvSpPr/>
           <p:nvPr/>
         </p:nvSpPr>
         <p:spPr>
           <a:xfrm>
-            <a:off x="822960" y="3364991"/>
+            <a:off x="822960" y="3493008"/>
             <a:ext cx="2020824" cy="1389888"/>
           </a:xfrm>
           <a:prstGeom prst="roundRect">
@@ -34752,13 +34809,13 @@
       </p:sp>
       <p:sp>
         <p:nvSpPr>
-          <p:cNvPr id="7" name="Oval 6"/>
+          <p:cNvPr id="8" name="Oval 7"/>
           <p:cNvSpPr/>
           <p:nvPr/>
         </p:nvSpPr>
         <p:spPr>
           <a:xfrm>
-            <a:off x="804672" y="3246120"/>
+            <a:off x="804672" y="3374136"/>
             <a:ext cx="256032" cy="256032"/>
           </a:xfrm>
           <a:prstGeom prst="ellipse">
@@ -34805,13 +34862,13 @@
       </p:sp>
       <p:sp>
         <p:nvSpPr>
-          <p:cNvPr id="8" name="TextBox 7"/>
+          <p:cNvPr id="9" name="TextBox 8"/>
           <p:cNvSpPr txBox="1"/>
           <p:nvPr/>
         </p:nvSpPr>
         <p:spPr>
           <a:xfrm>
-            <a:off x="950976" y="3547872"/>
+            <a:off x="950976" y="3675887"/>
             <a:ext cx="1764792" cy="548640"/>
           </a:xfrm>
           <a:prstGeom prst="rect">
@@ -34840,13 +34897,13 @@
       </p:sp>
       <p:sp>
         <p:nvSpPr>
-          <p:cNvPr id="9" name="TextBox 8"/>
+          <p:cNvPr id="10" name="TextBox 9"/>
           <p:cNvSpPr txBox="1"/>
           <p:nvPr/>
         </p:nvSpPr>
         <p:spPr>
           <a:xfrm>
-            <a:off x="950976" y="4114800"/>
+            <a:off x="950976" y="4242816"/>
             <a:ext cx="1764792" cy="566928"/>
           </a:xfrm>
           <a:prstGeom prst="rect">
@@ -34875,13 +34932,13 @@
       </p:sp>
       <p:sp>
         <p:nvSpPr>
-          <p:cNvPr id="10" name="Rounded Rectangle 9"/>
+          <p:cNvPr id="11" name="Rounded Rectangle 10"/>
           <p:cNvSpPr/>
           <p:nvPr/>
         </p:nvSpPr>
         <p:spPr>
           <a:xfrm>
-            <a:off x="2948940" y="3364991"/>
+            <a:off x="2948940" y="3493008"/>
             <a:ext cx="2020824" cy="1389888"/>
           </a:xfrm>
           <a:prstGeom prst="roundRect">
@@ -34923,13 +34980,13 @@
       </p:sp>
       <p:sp>
         <p:nvSpPr>
-          <p:cNvPr id="11" name="Oval 10"/>
+          <p:cNvPr id="12" name="Oval 11"/>
           <p:cNvSpPr/>
           <p:nvPr/>
         </p:nvSpPr>
         <p:spPr>
           <a:xfrm>
-            <a:off x="2930652" y="3246120"/>
+            <a:off x="2930652" y="3374136"/>
             <a:ext cx="256032" cy="256032"/>
           </a:xfrm>
           <a:prstGeom prst="ellipse">
@@ -34976,13 +35033,13 @@
       </p:sp>
       <p:sp>
         <p:nvSpPr>
-          <p:cNvPr id="12" name="TextBox 11"/>
+          <p:cNvPr id="13" name="TextBox 12"/>
           <p:cNvSpPr txBox="1"/>
           <p:nvPr/>
         </p:nvSpPr>
         <p:spPr>
           <a:xfrm>
-            <a:off x="3076956" y="3547872"/>
+            <a:off x="3076956" y="3675887"/>
             <a:ext cx="1764792" cy="548640"/>
           </a:xfrm>
           <a:prstGeom prst="rect">
@@ -35011,13 +35068,13 @@
       </p:sp>
       <p:sp>
         <p:nvSpPr>
-          <p:cNvPr id="13" name="TextBox 12"/>
+          <p:cNvPr id="14" name="TextBox 13"/>
           <p:cNvSpPr txBox="1"/>
           <p:nvPr/>
         </p:nvSpPr>
         <p:spPr>
           <a:xfrm>
-            <a:off x="3076956" y="4114800"/>
+            <a:off x="3076956" y="4242816"/>
             <a:ext cx="1764792" cy="566928"/>
           </a:xfrm>
           <a:prstGeom prst="rect">
@@ -35046,13 +35103,13 @@
       </p:sp>
       <p:sp>
         <p:nvSpPr>
-          <p:cNvPr id="14" name="Rounded Rectangle 13"/>
+          <p:cNvPr id="15" name="Rounded Rectangle 14"/>
           <p:cNvSpPr/>
           <p:nvPr/>
         </p:nvSpPr>
         <p:spPr>
           <a:xfrm>
-            <a:off x="5074920" y="3364991"/>
+            <a:off x="5074920" y="3493008"/>
             <a:ext cx="2020824" cy="1389888"/>
           </a:xfrm>
           <a:prstGeom prst="roundRect">
@@ -35094,13 +35151,13 @@
       </p:sp>
       <p:sp>
         <p:nvSpPr>
-          <p:cNvPr id="15" name="Oval 14"/>
+          <p:cNvPr id="16" name="Oval 15"/>
           <p:cNvSpPr/>
           <p:nvPr/>
         </p:nvSpPr>
         <p:spPr>
           <a:xfrm>
-            <a:off x="5056632" y="3246120"/>
+            <a:off x="5056632" y="3374136"/>
             <a:ext cx="256032" cy="256032"/>
           </a:xfrm>
           <a:prstGeom prst="ellipse">
@@ -35147,13 +35204,13 @@
       </p:sp>
       <p:sp>
         <p:nvSpPr>
-          <p:cNvPr id="16" name="TextBox 15"/>
+          <p:cNvPr id="17" name="TextBox 16"/>
           <p:cNvSpPr txBox="1"/>
           <p:nvPr/>
         </p:nvSpPr>
         <p:spPr>
           <a:xfrm>
-            <a:off x="5202936" y="3547872"/>
+            <a:off x="5202936" y="3675887"/>
             <a:ext cx="1764792" cy="548640"/>
           </a:xfrm>
           <a:prstGeom prst="rect">
@@ -35182,13 +35239,13 @@
       </p:sp>
       <p:sp>
         <p:nvSpPr>
-          <p:cNvPr id="17" name="TextBox 16"/>
+          <p:cNvPr id="18" name="TextBox 17"/>
           <p:cNvSpPr txBox="1"/>
           <p:nvPr/>
         </p:nvSpPr>
         <p:spPr>
           <a:xfrm>
-            <a:off x="5202936" y="4114800"/>
+            <a:off x="5202936" y="4242816"/>
             <a:ext cx="1764792" cy="566928"/>
           </a:xfrm>
           <a:prstGeom prst="rect">
@@ -35217,13 +35274,13 @@
       </p:sp>
       <p:sp>
         <p:nvSpPr>
-          <p:cNvPr id="18" name="Rounded Rectangle 17"/>
+          <p:cNvPr id="19" name="Rounded Rectangle 18"/>
           <p:cNvSpPr/>
           <p:nvPr/>
         </p:nvSpPr>
         <p:spPr>
           <a:xfrm>
-            <a:off x="7200900" y="3364991"/>
+            <a:off x="7200900" y="3493008"/>
             <a:ext cx="2020824" cy="1389888"/>
           </a:xfrm>
           <a:prstGeom prst="roundRect">
@@ -35265,13 +35322,13 @@
       </p:sp>
       <p:sp>
         <p:nvSpPr>
-          <p:cNvPr id="19" name="Oval 18"/>
+          <p:cNvPr id="20" name="Oval 19"/>
           <p:cNvSpPr/>
           <p:nvPr/>
         </p:nvSpPr>
         <p:spPr>
           <a:xfrm>
-            <a:off x="7182612" y="3246120"/>
+            <a:off x="7182612" y="3374136"/>
             <a:ext cx="256032" cy="256032"/>
           </a:xfrm>
           <a:prstGeom prst="ellipse">
@@ -35318,13 +35375,13 @@
       </p:sp>
       <p:sp>
         <p:nvSpPr>
-          <p:cNvPr id="20" name="TextBox 19"/>
+          <p:cNvPr id="21" name="TextBox 20"/>
           <p:cNvSpPr txBox="1"/>
           <p:nvPr/>
         </p:nvSpPr>
         <p:spPr>
           <a:xfrm>
-            <a:off x="7328916" y="3547872"/>
+            <a:off x="7328916" y="3675887"/>
             <a:ext cx="1764792" cy="548640"/>
           </a:xfrm>
           <a:prstGeom prst="rect">
@@ -35353,13 +35410,13 @@
       </p:sp>
       <p:sp>
         <p:nvSpPr>
-          <p:cNvPr id="21" name="TextBox 20"/>
+          <p:cNvPr id="22" name="TextBox 21"/>
           <p:cNvSpPr txBox="1"/>
           <p:nvPr/>
         </p:nvSpPr>
         <p:spPr>
           <a:xfrm>
-            <a:off x="7328916" y="4114800"/>
+            <a:off x="7328916" y="4242816"/>
             <a:ext cx="1764792" cy="566928"/>
           </a:xfrm>
           <a:prstGeom prst="rect">
@@ -35388,13 +35445,13 @@
       </p:sp>
       <p:sp>
         <p:nvSpPr>
-          <p:cNvPr id="22" name="Rounded Rectangle 21"/>
+          <p:cNvPr id="23" name="Rounded Rectangle 22"/>
           <p:cNvSpPr/>
           <p:nvPr/>
         </p:nvSpPr>
         <p:spPr>
           <a:xfrm>
-            <a:off x="9326880" y="3364991"/>
+            <a:off x="9326880" y="3493008"/>
             <a:ext cx="2020824" cy="1389888"/>
           </a:xfrm>
           <a:prstGeom prst="roundRect">
@@ -35436,13 +35493,13 @@
       </p:sp>
       <p:sp>
         <p:nvSpPr>
-          <p:cNvPr id="23" name="Oval 22"/>
+          <p:cNvPr id="24" name="Oval 23"/>
           <p:cNvSpPr/>
           <p:nvPr/>
         </p:nvSpPr>
         <p:spPr>
           <a:xfrm>
-            <a:off x="9308592" y="3246120"/>
+            <a:off x="9308592" y="3374136"/>
             <a:ext cx="256032" cy="256032"/>
           </a:xfrm>
           <a:prstGeom prst="ellipse">
@@ -35489,13 +35546,13 @@
       </p:sp>
       <p:sp>
         <p:nvSpPr>
-          <p:cNvPr id="24" name="TextBox 23"/>
+          <p:cNvPr id="25" name="TextBox 24"/>
           <p:cNvSpPr txBox="1"/>
           <p:nvPr/>
         </p:nvSpPr>
         <p:spPr>
           <a:xfrm>
-            <a:off x="9454896" y="3547872"/>
+            <a:off x="9454896" y="3675887"/>
             <a:ext cx="1764792" cy="548640"/>
           </a:xfrm>
           <a:prstGeom prst="rect">
@@ -35524,13 +35581,13 @@
       </p:sp>
       <p:sp>
         <p:nvSpPr>
-          <p:cNvPr id="25" name="TextBox 24"/>
+          <p:cNvPr id="26" name="TextBox 25"/>
           <p:cNvSpPr txBox="1"/>
           <p:nvPr/>
         </p:nvSpPr>
         <p:spPr>
           <a:xfrm>
-            <a:off x="9454896" y="4114800"/>
+            <a:off x="9454896" y="4242816"/>
             <a:ext cx="1764792" cy="566928"/>
           </a:xfrm>
           <a:prstGeom prst="rect">
@@ -35559,13 +35616,13 @@
       </p:sp>
       <p:sp>
         <p:nvSpPr>
-          <p:cNvPr id="26" name="Rounded Rectangle 25"/>
+          <p:cNvPr id="27" name="Rounded Rectangle 26"/>
           <p:cNvSpPr/>
           <p:nvPr/>
         </p:nvSpPr>
         <p:spPr>
           <a:xfrm>
-            <a:off x="557784" y="5349240"/>
+            <a:off x="557784" y="5230368"/>
             <a:ext cx="11082528" cy="841248"/>
           </a:xfrm>
           <a:prstGeom prst="roundRect">
@@ -35605,13 +35662,13 @@
       </p:sp>
       <p:sp>
         <p:nvSpPr>
-          <p:cNvPr id="27" name="TextBox 26"/>
+          <p:cNvPr id="28" name="TextBox 27"/>
           <p:cNvSpPr txBox="1"/>
           <p:nvPr/>
         </p:nvSpPr>
         <p:spPr>
           <a:xfrm>
-            <a:off x="868680" y="5458968"/>
+            <a:off x="868680" y="5340096"/>
             <a:ext cx="10469880" cy="621792"/>
           </a:xfrm>
           <a:prstGeom prst="rect">
@@ -35662,13 +35719,13 @@
       </p:sp>
       <p:sp>
         <p:nvSpPr>
-          <p:cNvPr id="28" name="TextBox 27"/>
+          <p:cNvPr id="29" name="TextBox 28"/>
           <p:cNvSpPr txBox="1"/>
           <p:nvPr/>
         </p:nvSpPr>
         <p:spPr>
           <a:xfrm>
-            <a:off x="557784" y="6291072"/>
+            <a:off x="557784" y="6199632"/>
             <a:ext cx="11082528" cy="164592"/>
           </a:xfrm>
           <a:prstGeom prst="rect">

</xml_diff>

<commit_message>
Reframe platform-org question around true platform archetypes; add research brief
Co-Authored-By: Claude Fable 5 <noreply@anthropic.com>
Claude-Session: https://claude.ai/code/session_01A3Z3HHfQP1XqLkWjeuhpsJ
</commit_message>
<xml_diff>
--- a/proposal/TU_Org_AI_3pager_vDraft.pptx
+++ b/proposal/TU_Org_AI_3pager_vDraft.pptx
@@ -36752,7 +36752,7 @@
                 </a:solidFill>
                 <a:latin typeface="Arial"/>
               </a:rPr>
-              <a:t>What can TU learn from genuine platform orgs (e.g., Adobe) vs. general-manager-led models (e.g., Amazon, Google) — and which fits TU?</a:t>
+              <a:t>Which archetypes do true platform companies follow — central platform division (e.g., Atlassian, Salesforce), federated platform services (e.g., AWS) — and which is right for TU?</a:t>
             </a:r>
           </a:p>
         </p:txBody>
@@ -36765,7 +36765,7 @@
         </p:nvSpPr>
         <p:spPr>
           <a:xfrm>
-            <a:off x="5074920" y="5257800"/>
+            <a:off x="5074920" y="5472683"/>
             <a:ext cx="3145536" cy="731520"/>
           </a:xfrm>
           <a:prstGeom prst="rect">

</xml_diff>

<commit_message>
Merge edits into Parth's draft: setup line, Megha's platform questions, program-page ports
Co-Authored-By: Claude Fable 5 <noreply@anthropic.com>
Claude-Session: https://claude.ai/code/session_01A3Z3HHfQP1XqLkWjeuhpsJ
</commit_message>
<xml_diff>
--- a/proposal/TU_Org_AI_3pager_vDraft.pptx
+++ b/proposal/TU_Org_AI_3pager_vDraft.pptx
@@ -3599,7 +3599,7 @@
                 </a:solidFill>
                 <a:latin typeface="+mn-lt"/>
               </a:rPr>
-              <a:t>CONFIDENTIAL AND PROPRIETARY | © 2026 McKinsey &amp; Company. </a:t>
+              <a:t>CONFIDENTIAL AND PROPRIETARY | © [#] McKinsey &amp; Company. </a:t>
             </a:r>
           </a:p>
           <a:p>
@@ -34496,8 +34496,244 @@
         </p:nvSpPr>
         <p:spPr>
           <a:xfrm>
-            <a:off x="557784" y="1188720"/>
-            <a:ext cx="11082528" cy="502920"/>
+            <a:off x="557784" y="1645920"/>
+            <a:ext cx="5440680" cy="256032"/>
+          </a:xfrm>
+          <a:prstGeom prst="rect">
+            <a:avLst/>
+          </a:prstGeom>
+          <a:noFill/>
+        </p:spPr>
+        <p:txBody>
+          <a:bodyPr wrap="square" anchor="t" lIns="0" rIns="0" tIns="0" bIns="0">
+            <a:spAutoFit/>
+          </a:bodyPr>
+          <a:lstStyle/>
+          <a:p>
+            <a:pPr algn="l"/>
+            <a:r>
+              <a:rPr sz="1500" b="1" i="0">
+                <a:solidFill>
+                  <a:srgbClr val="000000"/>
+                </a:solidFill>
+                <a:latin typeface="Arial"/>
+              </a:rPr>
+              <a:t>A journey to prioritize where AI creates value</a:t>
+            </a:r>
+          </a:p>
+        </p:txBody>
+      </p:sp>
+      <p:cxnSp>
+        <p:nvCxnSpPr>
+          <p:cNvPr id="4" name="Connector 3"/>
+          <p:cNvCxnSpPr/>
+          <p:nvPr/>
+        </p:nvCxnSpPr>
+        <p:spPr>
+          <a:xfrm>
+            <a:off x="557784" y="1975104"/>
+            <a:ext cx="5440680" cy="0"/>
+          </a:xfrm>
+          <a:prstGeom prst="line">
+            <a:avLst/>
+          </a:prstGeom>
+          <a:ln w="9525">
+            <a:solidFill>
+              <a:srgbClr val="B0B3B8"/>
+            </a:solidFill>
+          </a:ln>
+          <a:effectLst/>
+        </p:spPr>
+        <p:style>
+          <a:lnRef idx="2">
+            <a:schemeClr val="accent1"/>
+          </a:lnRef>
+          <a:fillRef idx="0">
+            <a:schemeClr val="accent1"/>
+          </a:fillRef>
+          <a:effectRef idx="1">
+            <a:schemeClr val="accent1"/>
+          </a:effectRef>
+          <a:fontRef idx="minor">
+            <a:schemeClr val="tx1"/>
+          </a:fontRef>
+        </p:style>
+      </p:cxnSp>
+      <p:sp>
+        <p:nvSpPr>
+          <p:cNvPr id="5" name="TextBox 4"/>
+          <p:cNvSpPr txBox="1"/>
+          <p:nvPr/>
+        </p:nvSpPr>
+        <p:spPr>
+          <a:xfrm>
+            <a:off x="557784" y="2103120"/>
+            <a:ext cx="5440680" cy="1188720"/>
+          </a:xfrm>
+          <a:prstGeom prst="rect">
+            <a:avLst/>
+          </a:prstGeom>
+          <a:noFill/>
+        </p:spPr>
+        <p:txBody>
+          <a:bodyPr wrap="square" anchor="t" lIns="0" rIns="0" tIns="0" bIns="0">
+            <a:spAutoFit/>
+          </a:bodyPr>
+          <a:lstStyle/>
+          <a:p>
+            <a:pPr algn="l">
+              <a:lnSpc>
+                <a:spcPct val="100000"/>
+              </a:lnSpc>
+            </a:pPr>
+            <a:r>
+              <a:rPr sz="1300" b="0" i="0">
+                <a:solidFill>
+                  <a:srgbClr val="000000"/>
+                </a:solidFill>
+                <a:latin typeface="Arial"/>
+              </a:rPr>
+              <a:t>TU is embarking on a </a:t>
+            </a:r>
+            <a:r>
+              <a:rPr sz="1300" b="1" i="0">
+                <a:solidFill>
+                  <a:srgbClr val="000000"/>
+                </a:solidFill>
+                <a:latin typeface="Arial"/>
+              </a:rPr>
+              <a:t>top-down journey to identify and prioritize 2–3 enterprise domains</a:t>
+            </a:r>
+            <a:r>
+              <a:rPr sz="1300" b="0" i="0">
+                <a:solidFill>
+                  <a:srgbClr val="000000"/>
+                </a:solidFill>
+                <a:latin typeface="Arial"/>
+              </a:rPr>
+              <a:t> where AI-led reimagination can drive outsized value — the few cross-functional domains that typically hold </a:t>
+            </a:r>
+            <a:r>
+              <a:rPr sz="1300" b="1" i="0">
+                <a:solidFill>
+                  <a:srgbClr val="000000"/>
+                </a:solidFill>
+                <a:latin typeface="Arial"/>
+              </a:rPr>
+              <a:t>40–50% of the enterprise value at stake¹</a:t>
+            </a:r>
+          </a:p>
+          <a:p>
+            <a:pPr algn="l">
+              <a:lnSpc>
+                <a:spcPct val="100000"/>
+              </a:lnSpc>
+              <a:spcBef>
+                <a:spcPts val="700"/>
+              </a:spcBef>
+            </a:pPr>
+            <a:r>
+              <a:rPr sz="1300" b="0" i="0">
+                <a:solidFill>
+                  <a:srgbClr val="000000"/>
+                </a:solidFill>
+                <a:latin typeface="Arial"/>
+              </a:rPr>
+              <a:t>An inventory of AI initiatives is underway; the next step is a </a:t>
+            </a:r>
+            <a:r>
+              <a:rPr sz="1300" b="1" i="0">
+                <a:solidFill>
+                  <a:srgbClr val="000000"/>
+                </a:solidFill>
+                <a:latin typeface="Arial"/>
+              </a:rPr>
+              <a:t>framework to assess, size, and choose</a:t>
+            </a:r>
+          </a:p>
+        </p:txBody>
+      </p:sp>
+      <p:sp>
+        <p:nvSpPr>
+          <p:cNvPr id="6" name="TextBox 5"/>
+          <p:cNvSpPr txBox="1"/>
+          <p:nvPr/>
+        </p:nvSpPr>
+        <p:spPr>
+          <a:xfrm>
+            <a:off x="6190488" y="1645920"/>
+            <a:ext cx="5440680" cy="256032"/>
+          </a:xfrm>
+          <a:prstGeom prst="rect">
+            <a:avLst/>
+          </a:prstGeom>
+          <a:noFill/>
+        </p:spPr>
+        <p:txBody>
+          <a:bodyPr wrap="square" anchor="t" lIns="0" rIns="0" tIns="0" bIns="0">
+            <a:spAutoFit/>
+          </a:bodyPr>
+          <a:lstStyle/>
+          <a:p>
+            <a:pPr algn="l"/>
+            <a:r>
+              <a:rPr sz="1500" b="1" i="0">
+                <a:solidFill>
+                  <a:srgbClr val="000000"/>
+                </a:solidFill>
+                <a:latin typeface="Arial"/>
+              </a:rPr>
+              <a:t>An organization built for a different era</a:t>
+            </a:r>
+          </a:p>
+        </p:txBody>
+      </p:sp>
+      <p:cxnSp>
+        <p:nvCxnSpPr>
+          <p:cNvPr id="7" name="Connector 6"/>
+          <p:cNvCxnSpPr/>
+          <p:nvPr/>
+        </p:nvCxnSpPr>
+        <p:spPr>
+          <a:xfrm>
+            <a:off x="6190488" y="1975104"/>
+            <a:ext cx="5440680" cy="0"/>
+          </a:xfrm>
+          <a:prstGeom prst="line">
+            <a:avLst/>
+          </a:prstGeom>
+          <a:ln w="9525">
+            <a:solidFill>
+              <a:srgbClr val="B0B3B8"/>
+            </a:solidFill>
+          </a:ln>
+          <a:effectLst/>
+        </p:spPr>
+        <p:style>
+          <a:lnRef idx="2">
+            <a:schemeClr val="accent1"/>
+          </a:lnRef>
+          <a:fillRef idx="0">
+            <a:schemeClr val="accent1"/>
+          </a:fillRef>
+          <a:effectRef idx="1">
+            <a:schemeClr val="accent1"/>
+          </a:effectRef>
+          <a:fontRef idx="minor">
+            <a:schemeClr val="tx1"/>
+          </a:fontRef>
+        </p:style>
+      </p:cxnSp>
+      <p:sp>
+        <p:nvSpPr>
+          <p:cNvPr id="8" name="TextBox 7"/>
+          <p:cNvSpPr txBox="1"/>
+          <p:nvPr/>
+        </p:nvSpPr>
+        <p:spPr>
+          <a:xfrm>
+            <a:off x="6190488" y="2103120"/>
+            <a:ext cx="5440680" cy="1188720"/>
           </a:xfrm>
           <a:prstGeom prst="rect">
             <a:avLst/>
@@ -34516,63 +34752,73 @@
               </a:lnSpc>
             </a:pPr>
             <a:r>
-              <a:rPr sz="1350" b="0" i="0">
+              <a:rPr sz="1300" b="0" i="0">
                 <a:solidFill>
                   <a:srgbClr val="000000"/>
                 </a:solidFill>
                 <a:latin typeface="Arial"/>
               </a:rPr>
-              <a:t>TU has evolved from credit bureau, to product company, to </a:t>
+              <a:t>In parallel, TU must </a:t>
             </a:r>
             <a:r>
-              <a:rPr sz="1350" b="1" i="0">
+              <a:rPr sz="1300" b="1" i="0">
                 <a:solidFill>
                   <a:srgbClr val="000000"/>
                 </a:solidFill>
                 <a:latin typeface="Arial"/>
               </a:rPr>
-              <a:t>platform organization — thin products on thick platforms</a:t>
+              <a:t>design the organization of the future</a:t>
             </a:r>
             <a:r>
-              <a:rPr sz="1350" b="0" i="0">
+              <a:rPr sz="1300" b="0" i="0">
                 <a:solidFill>
                   <a:srgbClr val="000000"/>
                 </a:solidFill>
                 <a:latin typeface="Arial"/>
               </a:rPr>
-              <a:t> — and it has embarked on its AI journey, </a:t>
+              <a:t> — its structure has not kept pace with what it is becoming</a:t>
             </a:r>
+          </a:p>
+          <a:p>
+            <a:pPr>
+              <a:lnSpc>
+                <a:spcPct val="108000"/>
+              </a:lnSpc>
+              <a:spcBef>
+                <a:spcPts val="700"/>
+              </a:spcBef>
+            </a:pPr>
             <a:r>
-              <a:rPr sz="1350" b="1" i="0">
+              <a:rPr sz="1300" b="0" i="0">
                 <a:solidFill>
                   <a:srgbClr val="000000"/>
                 </a:solidFill>
                 <a:latin typeface="Arial"/>
               </a:rPr>
-              <a:t>albeit still early</a:t>
+              <a:t>In leadership's own framing: </a:t>
             </a:r>
             <a:r>
-              <a:rPr sz="1350" b="0" i="0">
+              <a:rPr sz="1300" b="1" i="1">
                 <a:solidFill>
-                  <a:srgbClr val="000000"/>
+                  <a:srgbClr val="2251FF"/>
                 </a:solidFill>
                 <a:latin typeface="Arial"/>
               </a:rPr>
-              <a:t>. Two journeys follow:</a:t>
+              <a:t>a global-platforms era company, in a 2012-era structure</a:t>
             </a:r>
           </a:p>
         </p:txBody>
       </p:sp>
       <p:sp>
         <p:nvSpPr>
-          <p:cNvPr id="4" name="TextBox 3"/>
+          <p:cNvPr id="9" name="TextBox 8"/>
           <p:cNvSpPr txBox="1"/>
           <p:nvPr/>
         </p:nvSpPr>
         <p:spPr>
           <a:xfrm>
-            <a:off x="557784" y="1847088"/>
-            <a:ext cx="11082528" cy="777240"/>
+            <a:off x="557784" y="3438144"/>
+            <a:ext cx="11082528" cy="274320"/>
           </a:xfrm>
           <a:prstGeom prst="rect">
             <a:avLst/>
@@ -34591,188 +34837,31 @@
               </a:lnSpc>
             </a:pPr>
             <a:r>
-              <a:rPr sz="1350" b="0" i="0">
+              <a:rPr sz="1500" b="1" i="0">
                 <a:solidFill>
                   <a:srgbClr val="000000"/>
                 </a:solidFill>
                 <a:latin typeface="Arial"/>
               </a:rPr>
-              <a:t>TU is embarking on a </a:t>
-            </a:r>
-            <a:r>
-              <a:rPr sz="1350" b="1" i="0">
-                <a:solidFill>
-                  <a:srgbClr val="000000"/>
-                </a:solidFill>
-                <a:latin typeface="Arial"/>
-              </a:rPr>
-              <a:t>top-down journey to identify and prioritize 2–3 enterprise domains for AI-led reimagination</a:t>
-            </a:r>
-            <a:r>
-              <a:rPr sz="1350" b="0" i="0">
-                <a:solidFill>
-                  <a:srgbClr val="000000"/>
-                </a:solidFill>
-                <a:latin typeface="Arial"/>
-              </a:rPr>
-              <a:t> — the few cross-functional domains that typically hold </a:t>
-            </a:r>
-            <a:r>
-              <a:rPr sz="1350" b="1" i="0">
-                <a:solidFill>
-                  <a:srgbClr val="000000"/>
-                </a:solidFill>
-                <a:latin typeface="Arial"/>
-              </a:rPr>
-              <a:t>40–50% of the enterprise value at stake</a:t>
-            </a:r>
-            <a:r>
-              <a:rPr sz="1350" b="0" i="0">
-                <a:solidFill>
-                  <a:srgbClr val="000000"/>
-                </a:solidFill>
-                <a:latin typeface="Arial"/>
-              </a:rPr>
-              <a:t>¹. TU leadership has begun an inventory of AI initiatives; the next step is a </a:t>
-            </a:r>
-            <a:r>
-              <a:rPr sz="1350" b="1" i="0">
-                <a:solidFill>
-                  <a:srgbClr val="000000"/>
-                </a:solidFill>
-                <a:latin typeface="Arial"/>
-              </a:rPr>
-              <a:t>framework to assess, size, and choose where to focus</a:t>
+              <a:t>The organizational imperative spans five fronts</a:t>
             </a:r>
           </a:p>
         </p:txBody>
       </p:sp>
       <p:sp>
         <p:nvSpPr>
-          <p:cNvPr id="5" name="Rounded Rectangle 4"/>
+          <p:cNvPr id="10" name="Rounded Rectangle 9"/>
           <p:cNvSpPr/>
           <p:nvPr/>
         </p:nvSpPr>
         <p:spPr>
           <a:xfrm>
-            <a:off x="557784" y="2633472"/>
-            <a:ext cx="11082528" cy="2377440"/>
+            <a:off x="557784" y="3785616"/>
+            <a:ext cx="2139696" cy="1572768"/>
           </a:xfrm>
           <a:prstGeom prst="roundRect">
             <a:avLst>
-              <a:gd name="adj" fmla="val 3500"/>
-            </a:avLst>
-          </a:prstGeom>
-          <a:solidFill>
-            <a:srgbClr val="F0F4FF"/>
-          </a:solidFill>
-          <a:ln>
-            <a:noFill/>
-          </a:ln>
-          <a:effectLst/>
-        </p:spPr>
-        <p:style>
-          <a:lnRef idx="1">
-            <a:schemeClr val="accent1"/>
-          </a:lnRef>
-          <a:fillRef idx="3">
-            <a:schemeClr val="accent1"/>
-          </a:fillRef>
-          <a:effectRef idx="2">
-            <a:schemeClr val="accent1"/>
-          </a:effectRef>
-          <a:fontRef idx="minor">
-            <a:schemeClr val="lt1"/>
-          </a:fontRef>
-        </p:style>
-        <p:txBody>
-          <a:bodyPr rtlCol="0" anchor="ctr"/>
-          <a:lstStyle/>
-          <a:p>
-            <a:pPr algn="ctr"/>
-          </a:p>
-        </p:txBody>
-      </p:sp>
-      <p:sp>
-        <p:nvSpPr>
-          <p:cNvPr id="6" name="TextBox 5"/>
-          <p:cNvSpPr txBox="1"/>
-          <p:nvPr/>
-        </p:nvSpPr>
-        <p:spPr>
-          <a:xfrm>
-            <a:off x="822960" y="2761488"/>
-            <a:ext cx="10561320" cy="566928"/>
-          </a:xfrm>
-          <a:prstGeom prst="rect">
-            <a:avLst/>
-          </a:prstGeom>
-          <a:noFill/>
-        </p:spPr>
-        <p:txBody>
-          <a:bodyPr wrap="square" anchor="t" lIns="0" rIns="0" tIns="0" bIns="0">
-            <a:spAutoFit/>
-          </a:bodyPr>
-          <a:lstStyle/>
-          <a:p>
-            <a:pPr algn="l">
-              <a:lnSpc>
-                <a:spcPct val="108000"/>
-              </a:lnSpc>
-            </a:pPr>
-            <a:r>
-              <a:rPr sz="1350" b="1" i="0">
-                <a:solidFill>
-                  <a:srgbClr val="000000"/>
-                </a:solidFill>
-                <a:latin typeface="Arial"/>
-              </a:rPr>
-              <a:t>In parallel, TU must design the organization of the future.</a:t>
-            </a:r>
-            <a:r>
-              <a:rPr sz="1350" b="0" i="0">
-                <a:solidFill>
-                  <a:srgbClr val="000000"/>
-                </a:solidFill>
-                <a:latin typeface="Arial"/>
-              </a:rPr>
-              <a:t> Its structure has not kept pace with what it is becoming — in leadership's own framing, </a:t>
-            </a:r>
-            <a:r>
-              <a:rPr sz="1350" b="1" i="1">
-                <a:solidFill>
-                  <a:srgbClr val="2251FF"/>
-                </a:solidFill>
-                <a:latin typeface="Arial"/>
-              </a:rPr>
-              <a:t>a global-platforms era company, in a 2012-era structure.</a:t>
-            </a:r>
-            <a:r>
-              <a:rPr sz="1350" b="0" i="0">
-                <a:solidFill>
-                  <a:srgbClr val="000000"/>
-                </a:solidFill>
-                <a:latin typeface="Arial"/>
-              </a:rPr>
-              <a:t> The imperative spans five fronts:</a:t>
-            </a:r>
-          </a:p>
-        </p:txBody>
-      </p:sp>
-      <p:sp>
-        <p:nvSpPr>
-          <p:cNvPr id="7" name="Rounded Rectangle 6"/>
-          <p:cNvSpPr/>
-          <p:nvPr/>
-        </p:nvSpPr>
-        <p:spPr>
-          <a:xfrm>
-            <a:off x="822960" y="3493008"/>
-            <a:ext cx="2020824" cy="1389888"/>
-          </a:xfrm>
-          <a:prstGeom prst="roundRect">
-            <a:avLst>
-              <a:gd name="adj" fmla="val 9000"/>
+              <a:gd name="adj" fmla="val 8000"/>
             </a:avLst>
           </a:prstGeom>
           <a:solidFill>
@@ -34809,14 +34898,14 @@
       </p:sp>
       <p:sp>
         <p:nvSpPr>
-          <p:cNvPr id="8" name="Oval 7"/>
+          <p:cNvPr id="11" name="Oval 10"/>
           <p:cNvSpPr/>
           <p:nvPr/>
         </p:nvSpPr>
         <p:spPr>
           <a:xfrm>
-            <a:off x="804672" y="3374136"/>
-            <a:ext cx="256032" cy="256032"/>
+            <a:off x="539496" y="3666744"/>
+            <a:ext cx="274320" cy="274320"/>
           </a:xfrm>
           <a:prstGeom prst="ellipse">
             <a:avLst/>
@@ -34849,7 +34938,7 @@
           <a:p>
             <a:pPr algn="ctr"/>
             <a:r>
-              <a:rPr sz="1100" b="1">
+              <a:rPr sz="1200" b="1">
                 <a:solidFill>
                   <a:srgbClr val="FFFFFF"/>
                 </a:solidFill>
@@ -34862,14 +34951,14 @@
       </p:sp>
       <p:sp>
         <p:nvSpPr>
-          <p:cNvPr id="9" name="TextBox 8"/>
+          <p:cNvPr id="12" name="TextBox 11"/>
           <p:cNvSpPr txBox="1"/>
           <p:nvPr/>
         </p:nvSpPr>
         <p:spPr>
           <a:xfrm>
-            <a:off x="950976" y="3675887"/>
-            <a:ext cx="1764792" cy="548640"/>
+            <a:off x="704088" y="4005071"/>
+            <a:ext cx="1847088" cy="566928"/>
           </a:xfrm>
           <a:prstGeom prst="rect">
             <a:avLst/>
@@ -34884,7 +34973,7 @@
           <a:p>
             <a:pPr algn="l"/>
             <a:r>
-              <a:rPr sz="1250" b="1" i="0">
+              <a:rPr sz="1350" b="1" i="0">
                 <a:solidFill>
                   <a:srgbClr val="061F79"/>
                 </a:solidFill>
@@ -34897,14 +34986,14 @@
       </p:sp>
       <p:sp>
         <p:nvSpPr>
-          <p:cNvPr id="10" name="TextBox 9"/>
+          <p:cNvPr id="13" name="TextBox 12"/>
           <p:cNvSpPr txBox="1"/>
           <p:nvPr/>
         </p:nvSpPr>
         <p:spPr>
           <a:xfrm>
-            <a:off x="950976" y="4242816"/>
-            <a:ext cx="1764792" cy="566928"/>
+            <a:off x="704088" y="4590288"/>
+            <a:ext cx="1847088" cy="685800"/>
           </a:xfrm>
           <a:prstGeom prst="rect">
             <a:avLst/>
@@ -34919,7 +35008,7 @@
           <a:p>
             <a:pPr algn="l"/>
             <a:r>
-              <a:rPr sz="1050" b="0" i="0">
+              <a:rPr sz="1150" b="0" i="0">
                 <a:solidFill>
                   <a:srgbClr val="000000"/>
                 </a:solidFill>
@@ -34932,18 +35021,18 @@
       </p:sp>
       <p:sp>
         <p:nvSpPr>
-          <p:cNvPr id="11" name="Rounded Rectangle 10"/>
+          <p:cNvPr id="14" name="Rounded Rectangle 13"/>
           <p:cNvSpPr/>
           <p:nvPr/>
         </p:nvSpPr>
         <p:spPr>
           <a:xfrm>
-            <a:off x="2948940" y="3493008"/>
-            <a:ext cx="2020824" cy="1389888"/>
+            <a:off x="2793491" y="3785616"/>
+            <a:ext cx="2139696" cy="1572768"/>
           </a:xfrm>
           <a:prstGeom prst="roundRect">
             <a:avLst>
-              <a:gd name="adj" fmla="val 9000"/>
+              <a:gd name="adj" fmla="val 8000"/>
             </a:avLst>
           </a:prstGeom>
           <a:solidFill>
@@ -34980,14 +35069,14 @@
       </p:sp>
       <p:sp>
         <p:nvSpPr>
-          <p:cNvPr id="12" name="Oval 11"/>
+          <p:cNvPr id="15" name="Oval 14"/>
           <p:cNvSpPr/>
           <p:nvPr/>
         </p:nvSpPr>
         <p:spPr>
           <a:xfrm>
-            <a:off x="2930652" y="3374136"/>
-            <a:ext cx="256032" cy="256032"/>
+            <a:off x="2775203" y="3666744"/>
+            <a:ext cx="274320" cy="274320"/>
           </a:xfrm>
           <a:prstGeom prst="ellipse">
             <a:avLst/>
@@ -35020,7 +35109,7 @@
           <a:p>
             <a:pPr algn="ctr"/>
             <a:r>
-              <a:rPr sz="1100" b="1">
+              <a:rPr sz="1200" b="1">
                 <a:solidFill>
                   <a:srgbClr val="FFFFFF"/>
                 </a:solidFill>
@@ -35033,14 +35122,14 @@
       </p:sp>
       <p:sp>
         <p:nvSpPr>
-          <p:cNvPr id="13" name="TextBox 12"/>
+          <p:cNvPr id="16" name="TextBox 15"/>
           <p:cNvSpPr txBox="1"/>
           <p:nvPr/>
         </p:nvSpPr>
         <p:spPr>
           <a:xfrm>
-            <a:off x="3076956" y="3675887"/>
-            <a:ext cx="1764792" cy="548640"/>
+            <a:off x="2939796" y="4005071"/>
+            <a:ext cx="1847088" cy="566928"/>
           </a:xfrm>
           <a:prstGeom prst="rect">
             <a:avLst/>
@@ -35055,7 +35144,7 @@
           <a:p>
             <a:pPr algn="l"/>
             <a:r>
-              <a:rPr sz="1250" b="1" i="0">
+              <a:rPr sz="1350" b="1" i="0">
                 <a:solidFill>
                   <a:srgbClr val="061F79"/>
                 </a:solidFill>
@@ -35068,14 +35157,14 @@
       </p:sp>
       <p:sp>
         <p:nvSpPr>
-          <p:cNvPr id="14" name="TextBox 13"/>
+          <p:cNvPr id="17" name="TextBox 16"/>
           <p:cNvSpPr txBox="1"/>
           <p:nvPr/>
         </p:nvSpPr>
         <p:spPr>
           <a:xfrm>
-            <a:off x="3076956" y="4242816"/>
-            <a:ext cx="1764792" cy="566928"/>
+            <a:off x="2939796" y="4590288"/>
+            <a:ext cx="1847088" cy="685800"/>
           </a:xfrm>
           <a:prstGeom prst="rect">
             <a:avLst/>
@@ -35090,7 +35179,7 @@
           <a:p>
             <a:pPr algn="l"/>
             <a:r>
-              <a:rPr sz="1050" b="0" i="0">
+              <a:rPr sz="1150" b="0" i="0">
                 <a:solidFill>
                   <a:srgbClr val="000000"/>
                 </a:solidFill>
@@ -35103,18 +35192,18 @@
       </p:sp>
       <p:sp>
         <p:nvSpPr>
-          <p:cNvPr id="15" name="Rounded Rectangle 14"/>
+          <p:cNvPr id="18" name="Rounded Rectangle 17"/>
           <p:cNvSpPr/>
           <p:nvPr/>
         </p:nvSpPr>
         <p:spPr>
           <a:xfrm>
-            <a:off x="5074920" y="3493008"/>
-            <a:ext cx="2020824" cy="1389888"/>
+            <a:off x="5029200" y="3785616"/>
+            <a:ext cx="2139696" cy="1572768"/>
           </a:xfrm>
           <a:prstGeom prst="roundRect">
             <a:avLst>
-              <a:gd name="adj" fmla="val 9000"/>
+              <a:gd name="adj" fmla="val 8000"/>
             </a:avLst>
           </a:prstGeom>
           <a:solidFill>
@@ -35151,14 +35240,14 @@
       </p:sp>
       <p:sp>
         <p:nvSpPr>
-          <p:cNvPr id="16" name="Oval 15"/>
+          <p:cNvPr id="19" name="Oval 18"/>
           <p:cNvSpPr/>
           <p:nvPr/>
         </p:nvSpPr>
         <p:spPr>
           <a:xfrm>
-            <a:off x="5056632" y="3374136"/>
-            <a:ext cx="256032" cy="256032"/>
+            <a:off x="5010912" y="3666744"/>
+            <a:ext cx="274320" cy="274320"/>
           </a:xfrm>
           <a:prstGeom prst="ellipse">
             <a:avLst/>
@@ -35191,7 +35280,7 @@
           <a:p>
             <a:pPr algn="ctr"/>
             <a:r>
-              <a:rPr sz="1100" b="1">
+              <a:rPr sz="1200" b="1">
                 <a:solidFill>
                   <a:srgbClr val="FFFFFF"/>
                 </a:solidFill>
@@ -35204,14 +35293,14 @@
       </p:sp>
       <p:sp>
         <p:nvSpPr>
-          <p:cNvPr id="17" name="TextBox 16"/>
+          <p:cNvPr id="20" name="TextBox 19"/>
           <p:cNvSpPr txBox="1"/>
           <p:nvPr/>
         </p:nvSpPr>
         <p:spPr>
           <a:xfrm>
-            <a:off x="5202936" y="3675887"/>
-            <a:ext cx="1764792" cy="548640"/>
+            <a:off x="5175504" y="4005071"/>
+            <a:ext cx="1847088" cy="566928"/>
           </a:xfrm>
           <a:prstGeom prst="rect">
             <a:avLst/>
@@ -35226,7 +35315,7 @@
           <a:p>
             <a:pPr algn="l"/>
             <a:r>
-              <a:rPr sz="1250" b="1" i="0">
+              <a:rPr sz="1350" b="1" i="0">
                 <a:solidFill>
                   <a:srgbClr val="061F79"/>
                 </a:solidFill>
@@ -35239,14 +35328,14 @@
       </p:sp>
       <p:sp>
         <p:nvSpPr>
-          <p:cNvPr id="18" name="TextBox 17"/>
+          <p:cNvPr id="21" name="TextBox 20"/>
           <p:cNvSpPr txBox="1"/>
           <p:nvPr/>
         </p:nvSpPr>
         <p:spPr>
           <a:xfrm>
-            <a:off x="5202936" y="4242816"/>
-            <a:ext cx="1764792" cy="566928"/>
+            <a:off x="5175504" y="4590288"/>
+            <a:ext cx="1847088" cy="685800"/>
           </a:xfrm>
           <a:prstGeom prst="rect">
             <a:avLst/>
@@ -35261,7 +35350,7 @@
           <a:p>
             <a:pPr algn="l"/>
             <a:r>
-              <a:rPr sz="1050" b="0" i="0">
+              <a:rPr sz="1150" b="0" i="0">
                 <a:solidFill>
                   <a:srgbClr val="000000"/>
                 </a:solidFill>
@@ -35274,18 +35363,18 @@
       </p:sp>
       <p:sp>
         <p:nvSpPr>
-          <p:cNvPr id="19" name="Rounded Rectangle 18"/>
+          <p:cNvPr id="22" name="Rounded Rectangle 21"/>
           <p:cNvSpPr/>
           <p:nvPr/>
         </p:nvSpPr>
         <p:spPr>
           <a:xfrm>
-            <a:off x="7200900" y="3493008"/>
-            <a:ext cx="2020824" cy="1389888"/>
+            <a:off x="7264907" y="3785616"/>
+            <a:ext cx="2139696" cy="1572768"/>
           </a:xfrm>
           <a:prstGeom prst="roundRect">
             <a:avLst>
-              <a:gd name="adj" fmla="val 9000"/>
+              <a:gd name="adj" fmla="val 8000"/>
             </a:avLst>
           </a:prstGeom>
           <a:solidFill>
@@ -35322,14 +35411,14 @@
       </p:sp>
       <p:sp>
         <p:nvSpPr>
-          <p:cNvPr id="20" name="Oval 19"/>
+          <p:cNvPr id="23" name="Oval 22"/>
           <p:cNvSpPr/>
           <p:nvPr/>
         </p:nvSpPr>
         <p:spPr>
           <a:xfrm>
-            <a:off x="7182612" y="3374136"/>
-            <a:ext cx="256032" cy="256032"/>
+            <a:off x="7246620" y="3666744"/>
+            <a:ext cx="274320" cy="274320"/>
           </a:xfrm>
           <a:prstGeom prst="ellipse">
             <a:avLst/>
@@ -35362,7 +35451,7 @@
           <a:p>
             <a:pPr algn="ctr"/>
             <a:r>
-              <a:rPr sz="1100" b="1">
+              <a:rPr sz="1200" b="1">
                 <a:solidFill>
                   <a:srgbClr val="FFFFFF"/>
                 </a:solidFill>
@@ -35375,14 +35464,14 @@
       </p:sp>
       <p:sp>
         <p:nvSpPr>
-          <p:cNvPr id="21" name="TextBox 20"/>
+          <p:cNvPr id="24" name="TextBox 23"/>
           <p:cNvSpPr txBox="1"/>
           <p:nvPr/>
         </p:nvSpPr>
         <p:spPr>
           <a:xfrm>
-            <a:off x="7328916" y="3675887"/>
-            <a:ext cx="1764792" cy="548640"/>
+            <a:off x="7411211" y="4005071"/>
+            <a:ext cx="1847088" cy="566928"/>
           </a:xfrm>
           <a:prstGeom prst="rect">
             <a:avLst/>
@@ -35397,7 +35486,7 @@
           <a:p>
             <a:pPr algn="l"/>
             <a:r>
-              <a:rPr sz="1250" b="1" i="0">
+              <a:rPr sz="1350" b="1" i="0">
                 <a:solidFill>
                   <a:srgbClr val="061F79"/>
                 </a:solidFill>
@@ -35410,14 +35499,14 @@
       </p:sp>
       <p:sp>
         <p:nvSpPr>
-          <p:cNvPr id="22" name="TextBox 21"/>
+          <p:cNvPr id="25" name="TextBox 24"/>
           <p:cNvSpPr txBox="1"/>
           <p:nvPr/>
         </p:nvSpPr>
         <p:spPr>
           <a:xfrm>
-            <a:off x="7328916" y="4242816"/>
-            <a:ext cx="1764792" cy="566928"/>
+            <a:off x="7411211" y="4590288"/>
+            <a:ext cx="1847088" cy="685800"/>
           </a:xfrm>
           <a:prstGeom prst="rect">
             <a:avLst/>
@@ -35432,7 +35521,7 @@
           <a:p>
             <a:pPr algn="l"/>
             <a:r>
-              <a:rPr sz="1050" b="0" i="0">
+              <a:rPr sz="1150" b="0" i="0">
                 <a:solidFill>
                   <a:srgbClr val="000000"/>
                 </a:solidFill>
@@ -35445,18 +35534,18 @@
       </p:sp>
       <p:sp>
         <p:nvSpPr>
-          <p:cNvPr id="23" name="Rounded Rectangle 22"/>
+          <p:cNvPr id="26" name="Rounded Rectangle 25"/>
           <p:cNvSpPr/>
           <p:nvPr/>
         </p:nvSpPr>
         <p:spPr>
           <a:xfrm>
-            <a:off x="9326880" y="3493008"/>
-            <a:ext cx="2020824" cy="1389888"/>
+            <a:off x="9500615" y="3785616"/>
+            <a:ext cx="2139696" cy="1572768"/>
           </a:xfrm>
           <a:prstGeom prst="roundRect">
             <a:avLst>
-              <a:gd name="adj" fmla="val 9000"/>
+              <a:gd name="adj" fmla="val 8000"/>
             </a:avLst>
           </a:prstGeom>
           <a:solidFill>
@@ -35493,14 +35582,14 @@
       </p:sp>
       <p:sp>
         <p:nvSpPr>
-          <p:cNvPr id="24" name="Oval 23"/>
+          <p:cNvPr id="27" name="Oval 26"/>
           <p:cNvSpPr/>
           <p:nvPr/>
         </p:nvSpPr>
         <p:spPr>
           <a:xfrm>
-            <a:off x="9308592" y="3374136"/>
-            <a:ext cx="256032" cy="256032"/>
+            <a:off x="9482328" y="3666744"/>
+            <a:ext cx="274320" cy="274320"/>
           </a:xfrm>
           <a:prstGeom prst="ellipse">
             <a:avLst/>
@@ -35533,7 +35622,7 @@
           <a:p>
             <a:pPr algn="ctr"/>
             <a:r>
-              <a:rPr sz="1100" b="1">
+              <a:rPr sz="1200" b="1">
                 <a:solidFill>
                   <a:srgbClr val="FFFFFF"/>
                 </a:solidFill>
@@ -35546,14 +35635,14 @@
       </p:sp>
       <p:sp>
         <p:nvSpPr>
-          <p:cNvPr id="25" name="TextBox 24"/>
+          <p:cNvPr id="28" name="TextBox 27"/>
           <p:cNvSpPr txBox="1"/>
           <p:nvPr/>
         </p:nvSpPr>
         <p:spPr>
           <a:xfrm>
-            <a:off x="9454896" y="3675887"/>
-            <a:ext cx="1764792" cy="548640"/>
+            <a:off x="9646919" y="4005071"/>
+            <a:ext cx="1847088" cy="566928"/>
           </a:xfrm>
           <a:prstGeom prst="rect">
             <a:avLst/>
@@ -35568,7 +35657,7 @@
           <a:p>
             <a:pPr algn="l"/>
             <a:r>
-              <a:rPr sz="1250" b="1" i="0">
+              <a:rPr sz="1350" b="1" i="0">
                 <a:solidFill>
                   <a:srgbClr val="061F79"/>
                 </a:solidFill>
@@ -35581,14 +35670,14 @@
       </p:sp>
       <p:sp>
         <p:nvSpPr>
-          <p:cNvPr id="26" name="TextBox 25"/>
+          <p:cNvPr id="29" name="TextBox 28"/>
           <p:cNvSpPr txBox="1"/>
           <p:nvPr/>
         </p:nvSpPr>
         <p:spPr>
           <a:xfrm>
-            <a:off x="9454896" y="4242816"/>
-            <a:ext cx="1764792" cy="566928"/>
+            <a:off x="9646919" y="4590288"/>
+            <a:ext cx="1847088" cy="685800"/>
           </a:xfrm>
           <a:prstGeom prst="rect">
             <a:avLst/>
@@ -35603,7 +35692,7 @@
           <a:p>
             <a:pPr algn="l"/>
             <a:r>
-              <a:rPr sz="1050" b="0" i="0">
+              <a:rPr sz="1150" b="0" i="0">
                 <a:solidFill>
                   <a:srgbClr val="000000"/>
                 </a:solidFill>
@@ -35616,13 +35705,13 @@
       </p:sp>
       <p:sp>
         <p:nvSpPr>
-          <p:cNvPr id="27" name="Rounded Rectangle 26"/>
+          <p:cNvPr id="30" name="Rounded Rectangle 29"/>
           <p:cNvSpPr/>
           <p:nvPr/>
         </p:nvSpPr>
         <p:spPr>
           <a:xfrm>
-            <a:off x="557784" y="5230368"/>
+            <a:off x="557784" y="5532120"/>
             <a:ext cx="11082528" cy="841248"/>
           </a:xfrm>
           <a:prstGeom prst="roundRect">
@@ -35662,13 +35751,13 @@
       </p:sp>
       <p:sp>
         <p:nvSpPr>
-          <p:cNvPr id="28" name="TextBox 27"/>
+          <p:cNvPr id="31" name="TextBox 30"/>
           <p:cNvSpPr txBox="1"/>
           <p:nvPr/>
         </p:nvSpPr>
         <p:spPr>
           <a:xfrm>
-            <a:off x="868680" y="5340096"/>
+            <a:off x="868680" y="5641848"/>
             <a:ext cx="10469880" cy="621792"/>
           </a:xfrm>
           <a:prstGeom prst="rect">
@@ -35719,14 +35808,14 @@
       </p:sp>
       <p:sp>
         <p:nvSpPr>
-          <p:cNvPr id="29" name="TextBox 28"/>
+          <p:cNvPr id="32" name="TextBox 31"/>
           <p:cNvSpPr txBox="1"/>
           <p:nvPr/>
         </p:nvSpPr>
         <p:spPr>
           <a:xfrm>
-            <a:off x="557784" y="6199632"/>
-            <a:ext cx="11082528" cy="164592"/>
+            <a:off x="557784" y="1115568"/>
+            <a:ext cx="11082528" cy="420624"/>
           </a:xfrm>
           <a:prstGeom prst="rect">
             <a:avLst/>
@@ -35734,12 +35823,91 @@
           <a:noFill/>
         </p:spPr>
         <p:txBody>
-          <a:bodyPr wrap="square" anchor="t" lIns="0" rIns="0" tIns="0" bIns="0">
+          <a:bodyPr wrap="square" lIns="0" rIns="0" tIns="0" bIns="0">
             <a:spAutoFit/>
           </a:bodyPr>
           <a:lstStyle/>
           <a:p>
-            <a:pPr algn="l"/>
+            <a:pPr>
+              <a:lnSpc>
+                <a:spcPct val="108000"/>
+              </a:lnSpc>
+            </a:pPr>
+            <a:r>
+              <a:rPr sz="1300" b="0" i="0">
+                <a:solidFill>
+                  <a:srgbClr val="000000"/>
+                </a:solidFill>
+                <a:latin typeface="Arial"/>
+              </a:rPr>
+              <a:t>TU has evolved from credit bureau, to product company, to </a:t>
+            </a:r>
+            <a:r>
+              <a:rPr sz="1300" b="1" i="0">
+                <a:solidFill>
+                  <a:srgbClr val="000000"/>
+                </a:solidFill>
+                <a:latin typeface="Arial"/>
+              </a:rPr>
+              <a:t>platform organization — thin products on thick platforms</a:t>
+            </a:r>
+            <a:r>
+              <a:rPr sz="1300" b="0" i="0">
+                <a:solidFill>
+                  <a:srgbClr val="000000"/>
+                </a:solidFill>
+                <a:latin typeface="Arial"/>
+              </a:rPr>
+              <a:t> — and it has embarked on its AI journey, </a:t>
+            </a:r>
+            <a:r>
+              <a:rPr sz="1300" b="1" i="0">
+                <a:solidFill>
+                  <a:srgbClr val="000000"/>
+                </a:solidFill>
+                <a:latin typeface="Arial"/>
+              </a:rPr>
+              <a:t>albeit still early</a:t>
+            </a:r>
+            <a:r>
+              <a:rPr sz="1300" b="0" i="0">
+                <a:solidFill>
+                  <a:srgbClr val="000000"/>
+                </a:solidFill>
+                <a:latin typeface="Arial"/>
+              </a:rPr>
+              <a:t>. Two journeys follow:</a:t>
+            </a:r>
+          </a:p>
+        </p:txBody>
+      </p:sp>
+      <p:sp>
+        <p:nvSpPr>
+          <p:cNvPr id="33" name="TextBox 32"/>
+          <p:cNvSpPr txBox="1"/>
+          <p:nvPr/>
+        </p:nvSpPr>
+        <p:spPr>
+          <a:xfrm>
+            <a:off x="557784" y="6428232"/>
+            <a:ext cx="9601200" cy="146304"/>
+          </a:xfrm>
+          <a:prstGeom prst="rect">
+            <a:avLst/>
+          </a:prstGeom>
+          <a:noFill/>
+        </p:spPr>
+        <p:txBody>
+          <a:bodyPr wrap="square" lIns="0" rIns="0" tIns="0" bIns="0">
+            <a:spAutoFit/>
+          </a:bodyPr>
+          <a:lstStyle/>
+          <a:p>
+            <a:pPr>
+              <a:lnSpc>
+                <a:spcPct val="100000"/>
+              </a:lnSpc>
+            </a:pPr>
             <a:r>
               <a:rPr sz="850" b="0" i="0">
                 <a:solidFill>
@@ -35994,7 +36162,7 @@
         </p:nvSpPr>
         <p:spPr>
           <a:xfrm>
-            <a:off x="557784" y="2848356"/>
+            <a:off x="557784" y="2720340"/>
             <a:ext cx="256032" cy="256032"/>
           </a:xfrm>
           <a:prstGeom prst="ellipse">
@@ -36047,7 +36215,7 @@
         </p:nvSpPr>
         <p:spPr>
           <a:xfrm>
-            <a:off x="941832" y="2839212"/>
+            <a:off x="941832" y="2711196"/>
             <a:ext cx="3776472" cy="868680"/>
           </a:xfrm>
           <a:prstGeom prst="rect">
@@ -36095,7 +36263,7 @@
         </p:nvSpPr>
         <p:spPr>
           <a:xfrm>
-            <a:off x="557784" y="3886200"/>
+            <a:off x="557784" y="3630168"/>
             <a:ext cx="256032" cy="256032"/>
           </a:xfrm>
           <a:prstGeom prst="ellipse">
@@ -36148,7 +36316,7 @@
         </p:nvSpPr>
         <p:spPr>
           <a:xfrm>
-            <a:off x="941832" y="3877056"/>
+            <a:off x="941832" y="3621024"/>
             <a:ext cx="3776472" cy="868680"/>
           </a:xfrm>
           <a:prstGeom prst="rect">
@@ -36196,7 +36364,7 @@
         </p:nvSpPr>
         <p:spPr>
           <a:xfrm>
-            <a:off x="557784" y="4924044"/>
+            <a:off x="557784" y="4539996"/>
             <a:ext cx="256032" cy="256032"/>
           </a:xfrm>
           <a:prstGeom prst="ellipse">
@@ -36249,7 +36417,7 @@
         </p:nvSpPr>
         <p:spPr>
           <a:xfrm>
-            <a:off x="941832" y="4914900"/>
+            <a:off x="941832" y="4530852"/>
             <a:ext cx="3776472" cy="868680"/>
           </a:xfrm>
           <a:prstGeom prst="rect">
@@ -36297,7 +36465,7 @@
         </p:nvSpPr>
         <p:spPr>
           <a:xfrm>
-            <a:off x="557784" y="5737859"/>
+            <a:off x="557784" y="5225796"/>
             <a:ext cx="256032" cy="256032"/>
           </a:xfrm>
           <a:prstGeom prst="ellipse">
@@ -36350,7 +36518,7 @@
         </p:nvSpPr>
         <p:spPr>
           <a:xfrm>
-            <a:off x="941832" y="5728716"/>
+            <a:off x="941832" y="5216652"/>
             <a:ext cx="3776472" cy="868680"/>
           </a:xfrm>
           <a:prstGeom prst="rect">
@@ -36570,70 +36738,13 @@
               </a:lnSpc>
             </a:pPr>
             <a:r>
-              <a:rPr sz="1150" b="1" i="0">
-                <a:solidFill>
-                  <a:srgbClr val="000000"/>
-                </a:solidFill>
-                <a:latin typeface="Arial"/>
-              </a:rPr>
-              <a:t>– </a:t>
-            </a:r>
-            <a:r>
               <a:rPr sz="1150" b="0" i="0">
                 <a:solidFill>
                   <a:srgbClr val="000000"/>
                 </a:solidFill>
                 <a:latin typeface="Arial"/>
               </a:rPr>
-              <a:t>What does a right-sized TU look like — optimal spans, layers, and leadership density?</a:t>
-            </a:r>
-          </a:p>
-        </p:txBody>
-      </p:sp>
-      <p:sp>
-        <p:nvSpPr>
-          <p:cNvPr id="20" name="TextBox 19"/>
-          <p:cNvSpPr txBox="1"/>
-          <p:nvPr/>
-        </p:nvSpPr>
-        <p:spPr>
-          <a:xfrm>
-            <a:off x="5074920" y="2967228"/>
-            <a:ext cx="3145536" cy="731520"/>
-          </a:xfrm>
-          <a:prstGeom prst="rect">
-            <a:avLst/>
-          </a:prstGeom>
-          <a:noFill/>
-        </p:spPr>
-        <p:txBody>
-          <a:bodyPr wrap="square" anchor="t" lIns="0" rIns="0" tIns="0" bIns="0">
-            <a:spAutoFit/>
-          </a:bodyPr>
-          <a:lstStyle/>
-          <a:p>
-            <a:pPr algn="l">
-              <a:lnSpc>
-                <a:spcPct val="100000"/>
-              </a:lnSpc>
-            </a:pPr>
-            <a:r>
-              <a:rPr sz="1150" b="1" i="0">
-                <a:solidFill>
-                  <a:srgbClr val="000000"/>
-                </a:solidFill>
-                <a:latin typeface="Arial"/>
-              </a:rPr>
-              <a:t>– </a:t>
-            </a:r>
-            <a:r>
-              <a:rPr sz="1150" b="0" i="0">
-                <a:solidFill>
-                  <a:srgbClr val="000000"/>
-                </a:solidFill>
-                <a:latin typeface="Arial"/>
-              </a:rPr>
-              <a:t>Where does the structure deviate most from benchmark, and what value is at stake?</a:t>
+              <a:t>– What does a right-sized TU look like — optimal spans, layers, and leadership density — and what value is at stake vs. benchmark?</a:t>
             </a:r>
           </a:p>
         </p:txBody>
@@ -36646,7 +36757,7 @@
         </p:nvSpPr>
         <p:spPr>
           <a:xfrm>
-            <a:off x="5074920" y="3886200"/>
+            <a:off x="5074920" y="3044952"/>
             <a:ext cx="3145536" cy="219456"/>
           </a:xfrm>
           <a:prstGeom prst="rect">
@@ -36681,7 +36792,7 @@
         </p:nvCxnSpPr>
         <p:spPr>
           <a:xfrm>
-            <a:off x="5074920" y="4160520"/>
+            <a:off x="5074920" y="3319272"/>
             <a:ext cx="3145536" cy="0"/>
           </a:xfrm>
           <a:prstGeom prst="line">
@@ -36717,8 +36828,8 @@
         </p:nvSpPr>
         <p:spPr>
           <a:xfrm>
-            <a:off x="5074920" y="4270248"/>
-            <a:ext cx="3145536" cy="731520"/>
+            <a:off x="5074920" y="3429000"/>
+            <a:ext cx="3145536" cy="914400"/>
           </a:xfrm>
           <a:prstGeom prst="rect">
             <a:avLst/>
@@ -36737,22 +36848,13 @@
               </a:lnSpc>
             </a:pPr>
             <a:r>
-              <a:rPr sz="1150" b="1" i="0">
-                <a:solidFill>
-                  <a:srgbClr val="000000"/>
-                </a:solidFill>
-                <a:latin typeface="Arial"/>
-              </a:rPr>
-              <a:t>– </a:t>
-            </a:r>
-            <a:r>
               <a:rPr sz="1150" b="0" i="0">
                 <a:solidFill>
                   <a:srgbClr val="000000"/>
                 </a:solidFill>
                 <a:latin typeface="Arial"/>
               </a:rPr>
-              <a:t>Which archetypes do true platform companies follow — central platform division (e.g., Atlassian, Salesforce), federated platform services (e.g., AWS) — and which is right for TU?</a:t>
+              <a:t>– Which archetypes do true platform orgs follow — a central platform division (e.g., Atlassian, Salesforce) or federated services (e.g., AWS) — and which fits TU?</a:t>
             </a:r>
           </a:p>
         </p:txBody>
@@ -36765,8 +36867,8 @@
         </p:nvSpPr>
         <p:spPr>
           <a:xfrm>
-            <a:off x="5074920" y="5472683"/>
-            <a:ext cx="3145536" cy="731520"/>
+            <a:off x="5074920" y="4416552"/>
+            <a:ext cx="3145536" cy="1097280"/>
           </a:xfrm>
           <a:prstGeom prst="rect">
             <a:avLst/>
@@ -36785,22 +36887,13 @@
               </a:lnSpc>
             </a:pPr>
             <a:r>
-              <a:rPr sz="1150" b="1" i="0">
-                <a:solidFill>
-                  <a:srgbClr val="000000"/>
-                </a:solidFill>
-                <a:latin typeface="Arial"/>
-              </a:rPr>
-              <a:t>– </a:t>
-            </a:r>
-            <a:r>
               <a:rPr sz="1150" b="0" i="0">
                 <a:solidFill>
                   <a:srgbClr val="000000"/>
                 </a:solidFill>
                 <a:latin typeface="Arial"/>
               </a:rPr>
-              <a:t>What are the core design choices — US vs. international P&amp;L, regional vs. global layers, where technologists sit — and what must TU believe?</a:t>
+              <a:t>– What should be the size and composition of the platform and product engineering teams — and where should key roles reside (e.g., Platform PM, Data Science / Analytics, UI/UX)?</a:t>
             </a:r>
           </a:p>
         </p:txBody>
@@ -37028,7 +37121,7 @@
         </p:nvSpPr>
         <p:spPr>
           <a:xfrm>
-            <a:off x="8494776" y="4229100"/>
+            <a:off x="8494776" y="4265676"/>
             <a:ext cx="3145536" cy="219456"/>
           </a:xfrm>
           <a:prstGeom prst="rect">
@@ -37042,7 +37135,11 @@
           </a:bodyPr>
           <a:lstStyle/>
           <a:p>
-            <a:pPr algn="l"/>
+            <a:pPr algn="l">
+              <a:lnSpc>
+                <a:spcPct val="100000"/>
+              </a:lnSpc>
+            </a:pPr>
             <a:r>
               <a:rPr sz="1100" b="1" i="0">
                 <a:solidFill>
@@ -37063,7 +37160,7 @@
         </p:nvCxnSpPr>
         <p:spPr>
           <a:xfrm>
-            <a:off x="8494776" y="4503420"/>
+            <a:off x="8494776" y="4539996"/>
             <a:ext cx="3145535" cy="0"/>
           </a:xfrm>
           <a:prstGeom prst="line">
@@ -37099,7 +37196,7 @@
         </p:nvSpPr>
         <p:spPr>
           <a:xfrm>
-            <a:off x="8494776" y="4613148"/>
+            <a:off x="8494776" y="4649724"/>
             <a:ext cx="3145536" cy="731520"/>
           </a:xfrm>
           <a:prstGeom prst="rect">
@@ -37119,22 +37216,13 @@
               </a:lnSpc>
             </a:pPr>
             <a:r>
-              <a:rPr sz="1150" b="1" i="0">
-                <a:solidFill>
-                  <a:srgbClr val="000000"/>
-                </a:solidFill>
-                <a:latin typeface="Arial"/>
-              </a:rPr>
-              <a:t>– </a:t>
-            </a:r>
-            <a:r>
               <a:rPr sz="1150" b="0" i="0">
                 <a:solidFill>
                   <a:srgbClr val="000000"/>
                 </a:solidFill>
                 <a:latin typeface="Arial"/>
               </a:rPr>
-              <a:t>Which roles sit where under a refreshed GLS 2.0, and what moves now vs. later?</a:t>
+              <a:t>– Which roles sit where under a refreshed GLS 2.0, and what moves now vs. later?</a:t>
             </a:r>
           </a:p>
         </p:txBody>
@@ -37147,7 +37235,7 @@
         </p:nvSpPr>
         <p:spPr>
           <a:xfrm>
-            <a:off x="8494776" y="5317236"/>
+            <a:off x="8494776" y="5390388"/>
             <a:ext cx="3145536" cy="219456"/>
           </a:xfrm>
           <a:prstGeom prst="rect">
@@ -37182,7 +37270,7 @@
         </p:nvCxnSpPr>
         <p:spPr>
           <a:xfrm>
-            <a:off x="8494776" y="5591556"/>
+            <a:off x="8494776" y="5664708"/>
             <a:ext cx="3145535" cy="0"/>
           </a:xfrm>
           <a:prstGeom prst="line">
@@ -37218,7 +37306,7 @@
         </p:nvSpPr>
         <p:spPr>
           <a:xfrm>
-            <a:off x="8494776" y="5701284"/>
+            <a:off x="8494776" y="5774436"/>
             <a:ext cx="3145536" cy="731520"/>
           </a:xfrm>
           <a:prstGeom prst="rect">
@@ -37238,14 +37326,44 @@
               </a:lnSpc>
             </a:pPr>
             <a:r>
-              <a:rPr sz="1150" b="1" i="0">
+              <a:rPr sz="1150" b="0" i="0">
                 <a:solidFill>
                   <a:srgbClr val="000000"/>
                 </a:solidFill>
                 <a:latin typeface="Arial"/>
               </a:rPr>
-              <a:t>– </a:t>
+              <a:t>– What mindset and behavior shifts are needed — and can TU absorb the change?</a:t>
             </a:r>
+          </a:p>
+        </p:txBody>
+      </p:sp>
+      <p:sp>
+        <p:nvSpPr>
+          <p:cNvPr id="36" name="TextBox 35"/>
+          <p:cNvSpPr txBox="1"/>
+          <p:nvPr/>
+        </p:nvSpPr>
+        <p:spPr>
+          <a:xfrm>
+            <a:off x="5074920" y="5623560"/>
+            <a:ext cx="3145536" cy="731520"/>
+          </a:xfrm>
+          <a:prstGeom prst="rect">
+            <a:avLst/>
+          </a:prstGeom>
+          <a:noFill/>
+        </p:spPr>
+        <p:txBody>
+          <a:bodyPr wrap="square" lIns="0" rIns="0" tIns="0" bIns="0">
+            <a:spAutoFit/>
+          </a:bodyPr>
+          <a:lstStyle/>
+          <a:p>
+            <a:pPr>
+              <a:lnSpc>
+                <a:spcPct val="100000"/>
+              </a:lnSpc>
+            </a:pPr>
             <a:r>
               <a:rPr sz="1150" b="0" i="0">
                 <a:solidFill>
@@ -37253,7 +37371,7 @@
                 </a:solidFill>
                 <a:latin typeface="Arial"/>
               </a:rPr>
-              <a:t>What mindset and behavior shifts are needed — and can TU absorb the change?</a:t>
+              <a:t>– What are the core design choices — US vs. international P&amp;L, regional vs. global layers, platform as P&amp;L or cost center — and what must TU believe?</a:t>
             </a:r>
           </a:p>
         </p:txBody>
@@ -39375,7 +39493,7 @@
                 </a:solidFill>
                 <a:latin typeface="Arial"/>
               </a:rPr>
-              <a:t>Location footprint refresh (GLS 2.0)</a:t>
+              <a:t>Location footprint (GLS 2.0 refresh)</a:t>
             </a:r>
           </a:p>
         </p:txBody>
@@ -39473,8 +39591,8 @@
         </p:nvSpPr>
         <p:spPr>
           <a:xfrm>
-            <a:off x="557784" y="4974336"/>
-            <a:ext cx="7315200" cy="164592"/>
+            <a:off x="557784" y="4937760"/>
+            <a:ext cx="7315200" cy="182880"/>
           </a:xfrm>
           <a:prstGeom prst="rect">
             <a:avLst/>
@@ -39502,73 +39620,13 @@
       </p:sp>
       <p:sp>
         <p:nvSpPr>
-          <p:cNvPr id="60" name="TextBox 59"/>
-          <p:cNvSpPr txBox="1"/>
-          <p:nvPr/>
-        </p:nvSpPr>
-        <p:spPr>
-          <a:xfrm>
-            <a:off x="557784" y="5175504"/>
-            <a:ext cx="11082528" cy="310896"/>
-          </a:xfrm>
-          <a:prstGeom prst="rect">
-            <a:avLst/>
-          </a:prstGeom>
-          <a:noFill/>
-        </p:spPr>
-        <p:txBody>
-          <a:bodyPr wrap="square" anchor="t" lIns="0" rIns="0" tIns="0" bIns="0">
-            <a:spAutoFit/>
-          </a:bodyPr>
-          <a:lstStyle/>
-          <a:p>
-            <a:pPr algn="l"/>
-            <a:r>
-              <a:rPr sz="1050" b="1" i="0">
-                <a:solidFill>
-                  <a:srgbClr val="061F79"/>
-                </a:solidFill>
-                <a:latin typeface="Arial"/>
-              </a:rPr>
-              <a:t>By week 12:  </a:t>
-            </a:r>
-            <a:r>
-              <a:rPr sz="1050" b="0" i="0">
-                <a:solidFill>
-                  <a:srgbClr val="000000"/>
-                </a:solidFill>
-                <a:latin typeface="Arial"/>
-              </a:rPr>
-              <a:t>prioritized domain portfolio and value-backed roadmap  ·  target org blueprint and strategic workforce plan  ·  location and talent roadmap, with a 90-day mobilization plan</a:t>
-            </a:r>
-          </a:p>
-          <a:p>
-            <a:pPr algn="l">
-              <a:spcBef>
-                <a:spcPts val="300"/>
-              </a:spcBef>
-            </a:pPr>
-            <a:r>
-              <a:rPr sz="1050" b="0" i="0">
-                <a:solidFill>
-                  <a:srgbClr val="63666A"/>
-                </a:solidFill>
-                <a:latin typeface="Arial"/>
-              </a:rPr>
-              <a:t>Joint TU–McKinsey team; leadership checkpoints at weeks 2, 7, and 12</a:t>
-            </a:r>
-          </a:p>
-        </p:txBody>
-      </p:sp>
-      <p:sp>
-        <p:nvSpPr>
-          <p:cNvPr id="61" name="Rounded Rectangle 60"/>
+          <p:cNvPr id="60" name="Rounded Rectangle 59"/>
           <p:cNvSpPr/>
           <p:nvPr/>
         </p:nvSpPr>
         <p:spPr>
           <a:xfrm>
-            <a:off x="557784" y="5596128"/>
+            <a:off x="557784" y="5522976"/>
             <a:ext cx="11082528" cy="777240"/>
           </a:xfrm>
           <a:prstGeom prst="roundRect">
@@ -39614,7 +39672,7 @@
         </p:nvSpPr>
         <p:spPr>
           <a:xfrm>
-            <a:off x="868680" y="5678424"/>
+            <a:off x="868680" y="5605272"/>
             <a:ext cx="10469880" cy="621792"/>
           </a:xfrm>
           <a:prstGeom prst="rect">
@@ -39659,6 +39717,73 @@
                 <a:latin typeface="Arial"/>
               </a:rPr>
               <a:t>those learnings reset the top-down workforce plan on a regular cadence</a:t>
+            </a:r>
+          </a:p>
+        </p:txBody>
+      </p:sp>
+      <p:sp>
+        <p:nvSpPr>
+          <p:cNvPr id="63" name="TextBox 62"/>
+          <p:cNvSpPr txBox="1"/>
+          <p:nvPr/>
+        </p:nvSpPr>
+        <p:spPr>
+          <a:xfrm>
+            <a:off x="557784" y="5120640"/>
+            <a:ext cx="11082528" cy="329184"/>
+          </a:xfrm>
+          <a:prstGeom prst="rect">
+            <a:avLst/>
+          </a:prstGeom>
+          <a:noFill/>
+        </p:spPr>
+        <p:txBody>
+          <a:bodyPr wrap="square" lIns="0" rIns="0" tIns="0" bIns="0">
+            <a:spAutoFit/>
+          </a:bodyPr>
+          <a:lstStyle/>
+          <a:p>
+            <a:pPr>
+              <a:lnSpc>
+                <a:spcPct val="100000"/>
+              </a:lnSpc>
+            </a:pPr>
+            <a:r>
+              <a:rPr sz="1050" b="1" i="0">
+                <a:solidFill>
+                  <a:srgbClr val="061F79"/>
+                </a:solidFill>
+                <a:latin typeface="Arial"/>
+              </a:rPr>
+              <a:t>By week 12:  </a:t>
+            </a:r>
+            <a:r>
+              <a:rPr sz="1050" b="0" i="0">
+                <a:solidFill>
+                  <a:srgbClr val="000000"/>
+                </a:solidFill>
+                <a:latin typeface="Arial"/>
+              </a:rPr>
+              <a:t>prioritized domain portfolio and value-backed roadmap  ·  target org blueprint and strategic workforce plan  ·  location and talent roadmap, with a 90-day mobilization plan</a:t>
+            </a:r>
+          </a:p>
+          <a:p>
+            <a:pPr>
+              <a:lnSpc>
+                <a:spcPct val="100000"/>
+              </a:lnSpc>
+              <a:spcBef>
+                <a:spcPts val="300"/>
+              </a:spcBef>
+            </a:pPr>
+            <a:r>
+              <a:rPr sz="1050" b="0" i="0">
+                <a:solidFill>
+                  <a:srgbClr val="63666A"/>
+                </a:solidFill>
+                <a:latin typeface="Arial"/>
+              </a:rPr>
+              <a:t>Joint TU–McKinsey team; leadership checkpoints at weeks 2, 7, and 12</a:t>
             </a:r>
           </a:p>
         </p:txBody>

</xml_diff>